<commit_message>
Documentation in HTML format
</commit_message>
<xml_diff>
--- a/concept/genpackagedoc_concept.pptx
+++ b/concept/genpackagedoc_concept.pptx
@@ -5,7 +5,7 @@
     <p:sldMasterId id="2147483708" r:id="rId3"/>
   </p:sldMasterIdLst>
   <p:notesMasterIdLst>
-    <p:notesMasterId r:id="rId13"/>
+    <p:notesMasterId r:id="rId14"/>
   </p:notesMasterIdLst>
   <p:sldIdLst>
     <p:sldId id="256" r:id="rId4"/>
@@ -15,13 +15,14 @@
     <p:sldId id="300" r:id="rId8"/>
     <p:sldId id="299" r:id="rId9"/>
     <p:sldId id="301" r:id="rId10"/>
-    <p:sldId id="297" r:id="rId11"/>
-    <p:sldId id="296" r:id="rId12"/>
+    <p:sldId id="302" r:id="rId11"/>
+    <p:sldId id="297" r:id="rId12"/>
+    <p:sldId id="296" r:id="rId13"/>
   </p:sldIdLst>
   <p:sldSz cx="10969625" cy="6170613"/>
   <p:notesSz cx="6858000" cy="9144000"/>
   <p:custDataLst>
-    <p:tags r:id="rId14"/>
+    <p:tags r:id="rId15"/>
   </p:custDataLst>
   <p:defaultTextStyle>
     <a:defPPr>
@@ -160,6 +161,7 @@
             <p14:sldId id="300"/>
             <p14:sldId id="299"/>
             <p14:sldId id="301"/>
+            <p14:sldId id="302"/>
             <p14:sldId id="297"/>
             <p14:sldId id="296"/>
           </p14:sldIdLst>
@@ -258,7 +260,7 @@
           <a:p>
             <a:fld id="{6007911F-CEAF-4F0B-98BD-EFB38C6572AA}" type="datetimeFigureOut">
               <a:rPr lang="de-DE" smtClean="0"/>
-              <a:t>07.04.2026</a:t>
+              <a:t>21.04.2026</a:t>
             </a:fld>
             <a:endParaRPr lang="de-DE"/>
           </a:p>
@@ -9232,6 +9234,476 @@
 </p:sld>
 </file>
 
+<file path=ppt/slides/slide10.xml><?xml version="1.0" encoding="utf-8"?>
+<p:sld xmlns:a="http://schemas.openxmlformats.org/drawingml/2006/main" xmlns:r="http://schemas.openxmlformats.org/officeDocument/2006/relationships" xmlns:p="http://schemas.openxmlformats.org/presentationml/2006/main">
+  <p:cSld>
+    <p:spTree>
+      <p:nvGrpSpPr>
+        <p:cNvPr id="1" name="">
+          <a:extLst>
+            <a:ext uri="{FF2B5EF4-FFF2-40B4-BE49-F238E27FC236}">
+              <a16:creationId xmlns:a16="http://schemas.microsoft.com/office/drawing/2014/main" id="{CC87B0B3-6C56-A6F9-D687-40D1C5E1A8D4}"/>
+            </a:ext>
+          </a:extLst>
+        </p:cNvPr>
+        <p:cNvGrpSpPr/>
+        <p:nvPr/>
+      </p:nvGrpSpPr>
+      <p:grpSpPr>
+        <a:xfrm>
+          <a:off x="0" y="0"/>
+          <a:ext cx="0" cy="0"/>
+          <a:chOff x="0" y="0"/>
+          <a:chExt cx="0" cy="0"/>
+        </a:xfrm>
+      </p:grpSpPr>
+      <p:sp>
+        <p:nvSpPr>
+          <p:cNvPr id="3" name="Textplatzhalter 2">
+            <a:extLst>
+              <a:ext uri="{FF2B5EF4-FFF2-40B4-BE49-F238E27FC236}">
+                <a16:creationId xmlns:a16="http://schemas.microsoft.com/office/drawing/2014/main" id="{EACE1218-8F37-EF62-5767-F9500A4AA160}"/>
+              </a:ext>
+            </a:extLst>
+          </p:cNvPr>
+          <p:cNvSpPr>
+            <a:spLocks noGrp="1"/>
+          </p:cNvSpPr>
+          <p:nvPr>
+            <p:ph type="body" sz="quarter" idx="15"/>
+          </p:nvPr>
+        </p:nvSpPr>
+        <p:spPr/>
+        <p:txBody>
+          <a:bodyPr/>
+          <a:lstStyle/>
+          <a:p>
+            <a:r>
+              <a:rPr lang="de-DE" dirty="0"/>
+              <a:t>Code Objects (2)</a:t>
+            </a:r>
+            <a:endParaRPr lang="en-US" dirty="0"/>
+          </a:p>
+        </p:txBody>
+      </p:sp>
+      <p:sp>
+        <p:nvSpPr>
+          <p:cNvPr id="4" name="Foliennummernplatzhalter 3">
+            <a:extLst>
+              <a:ext uri="{FF2B5EF4-FFF2-40B4-BE49-F238E27FC236}">
+                <a16:creationId xmlns:a16="http://schemas.microsoft.com/office/drawing/2014/main" id="{46741DED-A3B8-781D-FAFD-62F2AB757746}"/>
+              </a:ext>
+            </a:extLst>
+          </p:cNvPr>
+          <p:cNvSpPr>
+            <a:spLocks noGrp="1"/>
+          </p:cNvSpPr>
+          <p:nvPr>
+            <p:ph type="sldNum" sz="quarter" idx="12"/>
+          </p:nvPr>
+        </p:nvSpPr>
+        <p:spPr/>
+        <p:txBody>
+          <a:bodyPr/>
+          <a:lstStyle/>
+          <a:p>
+            <a:fld id="{4898AEC0-503E-4FA4-859C-D0F72D6E3F79}" type="slidenum">
+              <a:rPr lang="en-US" noProof="1" smtClean="0"/>
+              <a:pPr/>
+              <a:t>10</a:t>
+            </a:fld>
+            <a:endParaRPr lang="en-US" noProof="1"/>
+          </a:p>
+        </p:txBody>
+      </p:sp>
+      <p:sp>
+        <p:nvSpPr>
+          <p:cNvPr id="2" name="Textfeld 116">
+            <a:extLst>
+              <a:ext uri="{FF2B5EF4-FFF2-40B4-BE49-F238E27FC236}">
+                <a16:creationId xmlns:a16="http://schemas.microsoft.com/office/drawing/2014/main" id="{D9D477F7-6B63-6CCC-5ED1-02DD6EA87A92}"/>
+              </a:ext>
+            </a:extLst>
+          </p:cNvPr>
+          <p:cNvSpPr txBox="1"/>
+          <p:nvPr/>
+        </p:nvSpPr>
+        <p:spPr>
+          <a:xfrm>
+            <a:off x="266699" y="849988"/>
+            <a:ext cx="5465233" cy="388800"/>
+          </a:xfrm>
+          <a:prstGeom prst="rect">
+            <a:avLst/>
+          </a:prstGeom>
+          <a:noFill/>
+        </p:spPr>
+        <p:txBody>
+          <a:bodyPr wrap="square" lIns="0" tIns="0" rIns="0" bIns="0" rtlCol="0">
+            <a:noAutofit/>
+          </a:bodyPr>
+          <a:lstStyle/>
+          <a:p>
+            <a:pPr marR="0" defTabSz="914400" eaLnBrk="1" fontAlgn="auto" latinLnBrk="0" hangingPunct="1">
+              <a:lnSpc>
+                <a:spcPts val="2300"/>
+              </a:lnSpc>
+              <a:spcBef>
+                <a:spcPts val="500"/>
+              </a:spcBef>
+              <a:spcAft>
+                <a:spcPts val="0"/>
+              </a:spcAft>
+              <a:buClrTx/>
+              <a:buSzTx/>
+              <a:buFontTx/>
+              <a:buNone/>
+              <a:tabLst/>
+            </a:pPr>
+            <a:r>
+              <a:rPr lang="de-DE" b="1" kern="0" dirty="0" err="1">
+                <a:solidFill>
+                  <a:srgbClr val="000000"/>
+                </a:solidFill>
+              </a:rPr>
+              <a:t>class</a:t>
+            </a:r>
+            <a:r>
+              <a:rPr lang="de-DE" b="1" kern="0" dirty="0">
+                <a:solidFill>
+                  <a:srgbClr val="000000"/>
+                </a:solidFill>
+              </a:rPr>
+              <a:t> </a:t>
+            </a:r>
+            <a:r>
+              <a:rPr lang="de-DE" b="1" kern="0" dirty="0" err="1">
+                <a:solidFill>
+                  <a:srgbClr val="000000"/>
+                </a:solidFill>
+              </a:rPr>
+              <a:t>CustomLaTeXTranslator</a:t>
+            </a:r>
+            <a:r>
+              <a:rPr lang="de-DE" b="1" kern="0" dirty="0">
+                <a:solidFill>
+                  <a:srgbClr val="000000"/>
+                </a:solidFill>
+              </a:rPr>
+              <a:t>(</a:t>
+            </a:r>
+            <a:r>
+              <a:rPr lang="de-DE" b="1" kern="0" dirty="0" err="1">
+                <a:solidFill>
+                  <a:srgbClr val="000000"/>
+                </a:solidFill>
+              </a:rPr>
+              <a:t>LaTeXTranslator</a:t>
+            </a:r>
+            <a:r>
+              <a:rPr lang="de-DE" b="1" kern="0" dirty="0">
+                <a:solidFill>
+                  <a:srgbClr val="000000"/>
+                </a:solidFill>
+              </a:rPr>
+              <a:t>):</a:t>
+            </a:r>
+          </a:p>
+        </p:txBody>
+      </p:sp>
+      <p:graphicFrame>
+        <p:nvGraphicFramePr>
+          <p:cNvPr id="38" name="Tabelle 37">
+            <a:extLst>
+              <a:ext uri="{FF2B5EF4-FFF2-40B4-BE49-F238E27FC236}">
+                <a16:creationId xmlns:a16="http://schemas.microsoft.com/office/drawing/2014/main" id="{A0C64C4A-3F37-0BFB-E1E8-F3396992A431}"/>
+              </a:ext>
+            </a:extLst>
+          </p:cNvPr>
+          <p:cNvGraphicFramePr>
+            <a:graphicFrameLocks noGrp="1"/>
+          </p:cNvGraphicFramePr>
+          <p:nvPr>
+            <p:extLst>
+              <p:ext uri="{D42A27DB-BD31-4B8C-83A1-F6EECF244321}">
+                <p14:modId xmlns:p14="http://schemas.microsoft.com/office/powerpoint/2010/main" val="119257365"/>
+              </p:ext>
+            </p:extLst>
+          </p:nvPr>
+        </p:nvGraphicFramePr>
+        <p:xfrm>
+          <a:off x="259200" y="1238788"/>
+          <a:ext cx="10298733" cy="2490203"/>
+        </p:xfrm>
+        <a:graphic>
+          <a:graphicData uri="http://schemas.openxmlformats.org/drawingml/2006/table">
+            <a:tbl>
+              <a:tblPr firstRow="1" bandRow="1">
+                <a:tableStyleId>{F5AB1C69-6EDB-4FF4-983F-18BD219EF322}</a:tableStyleId>
+              </a:tblPr>
+              <a:tblGrid>
+                <a:gridCol w="3432911">
+                  <a:extLst>
+                    <a:ext uri="{9D8B030D-6E8A-4147-A177-3AD203B41FA5}">
+                      <a16:colId xmlns:a16="http://schemas.microsoft.com/office/drawing/2014/main" val="43910445"/>
+                    </a:ext>
+                  </a:extLst>
+                </a:gridCol>
+                <a:gridCol w="3432911">
+                  <a:extLst>
+                    <a:ext uri="{9D8B030D-6E8A-4147-A177-3AD203B41FA5}">
+                      <a16:colId xmlns:a16="http://schemas.microsoft.com/office/drawing/2014/main" val="3741258493"/>
+                    </a:ext>
+                  </a:extLst>
+                </a:gridCol>
+                <a:gridCol w="3432911">
+                  <a:extLst>
+                    <a:ext uri="{9D8B030D-6E8A-4147-A177-3AD203B41FA5}">
+                      <a16:colId xmlns:a16="http://schemas.microsoft.com/office/drawing/2014/main" val="2562324463"/>
+                    </a:ext>
+                  </a:extLst>
+                </a:gridCol>
+              </a:tblGrid>
+              <a:tr h="478523">
+                <a:tc>
+                  <a:txBody>
+                    <a:bodyPr/>
+                    <a:lstStyle/>
+                    <a:p>
+                      <a:r>
+                        <a:rPr lang="de-DE" dirty="0" err="1">
+                          <a:solidFill>
+                            <a:schemeClr val="tx1"/>
+                          </a:solidFill>
+                        </a:rPr>
+                        <a:t>Markdown</a:t>
+                      </a:r>
+                      <a:endParaRPr lang="de-DE" dirty="0">
+                        <a:solidFill>
+                          <a:schemeClr val="tx1"/>
+                        </a:solidFill>
+                      </a:endParaRPr>
+                    </a:p>
+                  </a:txBody>
+                  <a:tcPr/>
+                </a:tc>
+                <a:tc>
+                  <a:txBody>
+                    <a:bodyPr/>
+                    <a:lstStyle/>
+                    <a:p>
+                      <a:r>
+                        <a:rPr lang="de-DE" dirty="0" err="1">
+                          <a:solidFill>
+                            <a:schemeClr val="tx1"/>
+                          </a:solidFill>
+                        </a:rPr>
+                        <a:t>LaTeX</a:t>
+                      </a:r>
+                      <a:endParaRPr lang="de-DE" dirty="0">
+                        <a:solidFill>
+                          <a:schemeClr val="tx1"/>
+                        </a:solidFill>
+                      </a:endParaRPr>
+                    </a:p>
+                  </a:txBody>
+                  <a:tcPr/>
+                </a:tc>
+                <a:tc>
+                  <a:txBody>
+                    <a:bodyPr/>
+                    <a:lstStyle/>
+                    <a:p>
+                      <a:r>
+                        <a:rPr lang="de-DE" dirty="0" err="1">
+                          <a:solidFill>
+                            <a:schemeClr val="tx1"/>
+                          </a:solidFill>
+                        </a:rPr>
+                        <a:t>Realized</a:t>
+                      </a:r>
+                      <a:r>
+                        <a:rPr lang="de-DE" dirty="0">
+                          <a:solidFill>
+                            <a:schemeClr val="tx1"/>
+                          </a:solidFill>
+                        </a:rPr>
+                        <a:t> </a:t>
+                      </a:r>
+                      <a:r>
+                        <a:rPr lang="de-DE" dirty="0" err="1">
+                          <a:solidFill>
+                            <a:schemeClr val="tx1"/>
+                          </a:solidFill>
+                        </a:rPr>
+                        <a:t>by</a:t>
+                      </a:r>
+                      <a:endParaRPr lang="de-DE" dirty="0">
+                        <a:solidFill>
+                          <a:schemeClr val="tx1"/>
+                        </a:solidFill>
+                      </a:endParaRPr>
+                    </a:p>
+                  </a:txBody>
+                  <a:tcPr/>
+                </a:tc>
+                <a:extLst>
+                  <a:ext uri="{0D108BD9-81ED-4DB2-BD59-A6C34878D82A}">
+                    <a16:rowId xmlns:a16="http://schemas.microsoft.com/office/drawing/2014/main" val="3297251498"/>
+                  </a:ext>
+                </a:extLst>
+              </a:tr>
+              <a:tr h="485169">
+                <a:tc>
+                  <a:txBody>
+                    <a:bodyPr/>
+                    <a:lstStyle/>
+                    <a:p>
+                      <a:r>
+                        <a:rPr lang="de-DE" dirty="0" err="1"/>
+                        <a:t>directive</a:t>
+                      </a:r>
+                      <a:r>
+                        <a:rPr lang="de-DE" dirty="0"/>
+                        <a:t>/</a:t>
+                      </a:r>
+                      <a:r>
+                        <a:rPr lang="de-DE" dirty="0" err="1"/>
+                        <a:t>rule</a:t>
+                      </a:r>
+                      <a:endParaRPr lang="de-DE" dirty="0"/>
+                    </a:p>
+                  </a:txBody>
+                  <a:tcPr/>
+                </a:tc>
+                <a:tc>
+                  <a:txBody>
+                    <a:bodyPr/>
+                    <a:lstStyle/>
+                    <a:p>
+                      <a:r>
+                        <a:rPr lang="de-DE" dirty="0" err="1"/>
+                        <a:t>environment</a:t>
+                      </a:r>
+                      <a:r>
+                        <a:rPr lang="de-DE" dirty="0"/>
+                        <a:t>/</a:t>
+                      </a:r>
+                      <a:r>
+                        <a:rPr lang="de-DE" dirty="0" err="1"/>
+                        <a:t>command</a:t>
+                      </a:r>
+                      <a:endParaRPr lang="de-DE" dirty="0"/>
+                    </a:p>
+                  </a:txBody>
+                  <a:tcPr/>
+                </a:tc>
+                <a:tc>
+                  <a:txBody>
+                    <a:bodyPr/>
+                    <a:lstStyle/>
+                    <a:p>
+                      <a:r>
+                        <a:rPr lang="en-US" dirty="0">
+                          <a:latin typeface="72 Monospace" panose="020B0509030603020204" pitchFamily="49" charset="0"/>
+                          <a:cs typeface="72 Monospace" panose="020B0509030603020204" pitchFamily="49" charset="0"/>
+                        </a:rPr>
+                        <a:t>from </a:t>
+                      </a:r>
+                      <a:r>
+                        <a:rPr lang="en-US" dirty="0" err="1">
+                          <a:latin typeface="72 Monospace" panose="020B0509030603020204" pitchFamily="49" charset="0"/>
+                          <a:cs typeface="72 Monospace" panose="020B0509030603020204" pitchFamily="49" charset="0"/>
+                        </a:rPr>
+                        <a:t>docutils.core</a:t>
+                      </a:r>
+                      <a:r>
+                        <a:rPr lang="en-US" dirty="0">
+                          <a:latin typeface="72 Monospace" panose="020B0509030603020204" pitchFamily="49" charset="0"/>
+                          <a:cs typeface="72 Monospace" panose="020B0509030603020204" pitchFamily="49" charset="0"/>
+                        </a:rPr>
+                        <a:t> import </a:t>
+                      </a:r>
+                      <a:r>
+                        <a:rPr lang="en-US" dirty="0" err="1">
+                          <a:latin typeface="72 Monospace" panose="020B0509030603020204" pitchFamily="49" charset="0"/>
+                          <a:cs typeface="72 Monospace" panose="020B0509030603020204" pitchFamily="49" charset="0"/>
+                        </a:rPr>
+                        <a:t>publish_parts</a:t>
+                      </a:r>
+                      <a:endParaRPr lang="en-US" dirty="0">
+                        <a:latin typeface="72 Monospace" panose="020B0509030603020204" pitchFamily="49" charset="0"/>
+                        <a:cs typeface="72 Monospace" panose="020B0509030603020204" pitchFamily="49" charset="0"/>
+                      </a:endParaRPr>
+                    </a:p>
+                    <a:p>
+                      <a:endParaRPr lang="en-US" dirty="0"/>
+                    </a:p>
+                    <a:p>
+                      <a:r>
+                        <a:rPr lang="en-US" dirty="0"/>
+                        <a:t>With:</a:t>
+                      </a:r>
+                    </a:p>
+                    <a:p>
+                      <a:endParaRPr lang="en-US" dirty="0"/>
+                    </a:p>
+                    <a:p>
+                      <a:r>
+                        <a:rPr lang="de-DE" dirty="0" err="1">
+                          <a:latin typeface="72 Monospace" panose="020B0509030603020204" pitchFamily="49" charset="0"/>
+                          <a:cs typeface="72 Monospace" panose="020B0509030603020204" pitchFamily="49" charset="0"/>
+                        </a:rPr>
+                        <a:t>writer</a:t>
+                      </a:r>
+                      <a:r>
+                        <a:rPr lang="de-DE" dirty="0">
+                          <a:latin typeface="72 Monospace" panose="020B0509030603020204" pitchFamily="49" charset="0"/>
+                          <a:cs typeface="72 Monospace" panose="020B0509030603020204" pitchFamily="49" charset="0"/>
+                        </a:rPr>
+                        <a:t>=</a:t>
+                      </a:r>
+                      <a:r>
+                        <a:rPr lang="de-DE" dirty="0" err="1">
+                          <a:latin typeface="72 Monospace" panose="020B0509030603020204" pitchFamily="49" charset="0"/>
+                          <a:cs typeface="72 Monospace" panose="020B0509030603020204" pitchFamily="49" charset="0"/>
+                        </a:rPr>
+                        <a:t>CustomLaTeXWriter</a:t>
+                      </a:r>
+                      <a:r>
+                        <a:rPr lang="de-DE" dirty="0">
+                          <a:latin typeface="72 Monospace" panose="020B0509030603020204" pitchFamily="49" charset="0"/>
+                          <a:cs typeface="72 Monospace" panose="020B0509030603020204" pitchFamily="49" charset="0"/>
+                        </a:rPr>
+                        <a:t>()</a:t>
+                      </a:r>
+                    </a:p>
+                  </a:txBody>
+                  <a:tcPr/>
+                </a:tc>
+                <a:extLst>
+                  <a:ext uri="{0D108BD9-81ED-4DB2-BD59-A6C34878D82A}">
+                    <a16:rowId xmlns:a16="http://schemas.microsoft.com/office/drawing/2014/main" val="3909443894"/>
+                  </a:ext>
+                </a:extLst>
+              </a:tr>
+            </a:tbl>
+          </a:graphicData>
+        </a:graphic>
+      </p:graphicFrame>
+    </p:spTree>
+    <p:extLst>
+      <p:ext uri="{BB962C8B-B14F-4D97-AF65-F5344CB8AC3E}">
+        <p14:creationId xmlns:p14="http://schemas.microsoft.com/office/powerpoint/2010/main" val="763922602"/>
+      </p:ext>
+    </p:extLst>
+  </p:cSld>
+  <p:clrMapOvr>
+    <a:masterClrMapping/>
+  </p:clrMapOvr>
+</p:sld>
+</file>
+
 <file path=ppt/slides/slide2.xml><?xml version="1.0" encoding="utf-8"?>
 <p:sld xmlns:a="http://schemas.openxmlformats.org/drawingml/2006/main" xmlns:r="http://schemas.openxmlformats.org/officeDocument/2006/relationships" xmlns:p="http://schemas.openxmlformats.org/presentationml/2006/main">
   <p:cSld>
@@ -9335,6 +9807,20 @@
               <a:tabLst/>
             </a:pPr>
             <a:r>
+              <a:rPr kumimoji="0" lang="de-DE" sz="1800" b="0" i="0" u="none" strike="noStrike" kern="0" cap="none" spc="0" normalizeH="0" baseline="0" noProof="0">
+                <a:ln>
+                  <a:noFill/>
+                </a:ln>
+                <a:solidFill>
+                  <a:srgbClr val="000000"/>
+                </a:solidFill>
+                <a:effectLst/>
+                <a:uLnTx/>
+                <a:uFillTx/>
+              </a:rPr>
+              <a:t>08.04.2026 </a:t>
+            </a:r>
+            <a:r>
               <a:rPr kumimoji="0" lang="de-DE" sz="1800" b="0" i="0" u="none" strike="noStrike" kern="0" cap="none" spc="0" normalizeH="0" baseline="0" noProof="0" dirty="0">
                 <a:ln>
                   <a:noFill/>
@@ -9346,7 +9832,7 @@
                 <a:uLnTx/>
                 <a:uFillTx/>
               </a:rPr>
-              <a:t>23.03.2026 / 0.1.0 / draft / XC-HWP/ESW3-Queckenstedt</a:t>
+              <a:t>/ 0.1.0 / draft / XC-HWP/ESW3-Queckenstedt</a:t>
             </a:r>
           </a:p>
           <a:p>
@@ -20297,6 +20783,2484 @@
           <a:lstStyle/>
           <a:p>
             <a:pPr marR="0" defTabSz="914400" eaLnBrk="1" fontAlgn="auto" latinLnBrk="0" hangingPunct="1">
+              <a:spcBef>
+                <a:spcPts val="500"/>
+              </a:spcBef>
+              <a:spcAft>
+                <a:spcPts val="0"/>
+              </a:spcAft>
+              <a:buClrTx/>
+              <a:buSzTx/>
+              <a:buFontTx/>
+              <a:buNone/>
+              <a:tabLst/>
+            </a:pPr>
+            <a:r>
+              <a:rPr kumimoji="0" lang="de-DE" sz="1200" i="0" u="none" strike="noStrike" kern="0" cap="none" spc="0" normalizeH="0" baseline="0" noProof="0" dirty="0">
+                <a:ln>
+                  <a:noFill/>
+                </a:ln>
+                <a:solidFill>
+                  <a:srgbClr val="000000"/>
+                </a:solidFill>
+                <a:effectLst/>
+                <a:uLnTx/>
+                <a:uFillTx/>
+              </a:rPr>
+              <a:t>With </a:t>
+            </a:r>
+            <a:r>
+              <a:rPr kumimoji="0" lang="de-DE" sz="1200" b="1" i="0" u="none" strike="noStrike" kern="0" cap="none" spc="0" normalizeH="0" baseline="0" noProof="0" dirty="0" err="1">
+                <a:ln>
+                  <a:noFill/>
+                </a:ln>
+                <a:solidFill>
+                  <a:srgbClr val="000000"/>
+                </a:solidFill>
+                <a:effectLst/>
+                <a:uLnTx/>
+                <a:uFillTx/>
+              </a:rPr>
+              <a:t>GenPackageDoc</a:t>
+            </a:r>
+            <a:r>
+              <a:rPr kumimoji="0" lang="de-DE" sz="1200" i="0" u="none" strike="noStrike" kern="0" cap="none" spc="0" normalizeH="0" baseline="0" noProof="0" dirty="0">
+                <a:ln>
+                  <a:noFill/>
+                </a:ln>
+                <a:solidFill>
+                  <a:srgbClr val="000000"/>
+                </a:solidFill>
+                <a:effectLst/>
+                <a:uLnTx/>
+                <a:uFillTx/>
+              </a:rPr>
+              <a:t> </a:t>
+            </a:r>
+            <a:r>
+              <a:rPr kumimoji="0" lang="de-DE" sz="1200" i="0" u="none" strike="noStrike" kern="0" cap="none" spc="0" normalizeH="0" baseline="0" noProof="0" dirty="0" err="1">
+                <a:ln>
+                  <a:noFill/>
+                </a:ln>
+                <a:solidFill>
+                  <a:srgbClr val="000000"/>
+                </a:solidFill>
+                <a:effectLst/>
+                <a:uLnTx/>
+                <a:uFillTx/>
+              </a:rPr>
+              <a:t>version</a:t>
+            </a:r>
+            <a:r>
+              <a:rPr kumimoji="0" lang="de-DE" sz="1200" i="0" u="none" strike="noStrike" kern="0" cap="none" spc="0" normalizeH="0" baseline="0" noProof="0" dirty="0">
+                <a:ln>
+                  <a:noFill/>
+                </a:ln>
+                <a:solidFill>
+                  <a:srgbClr val="000000"/>
+                </a:solidFill>
+                <a:effectLst/>
+                <a:uLnTx/>
+                <a:uFillTx/>
+              </a:rPr>
+              <a:t> </a:t>
+            </a:r>
+            <a:r>
+              <a:rPr kumimoji="0" lang="de-DE" sz="1200" b="1" i="0" u="none" strike="noStrike" kern="0" cap="none" spc="0" normalizeH="0" baseline="0" noProof="0" dirty="0">
+                <a:ln>
+                  <a:noFill/>
+                </a:ln>
+                <a:solidFill>
+                  <a:srgbClr val="000000"/>
+                </a:solidFill>
+                <a:effectLst/>
+                <a:uLnTx/>
+                <a:uFillTx/>
+              </a:rPr>
+              <a:t>0.43.0</a:t>
+            </a:r>
+            <a:r>
+              <a:rPr kumimoji="0" lang="de-DE" sz="1200" i="0" u="none" strike="noStrike" kern="0" cap="none" spc="0" normalizeH="0" baseline="0" noProof="0" dirty="0">
+                <a:ln>
+                  <a:noFill/>
+                </a:ln>
+                <a:solidFill>
+                  <a:srgbClr val="000000"/>
+                </a:solidFill>
+                <a:effectLst/>
+                <a:uLnTx/>
+                <a:uFillTx/>
+              </a:rPr>
+              <a:t>, </a:t>
+            </a:r>
+            <a:r>
+              <a:rPr kumimoji="0" lang="de-DE" sz="1200" i="0" u="none" strike="noStrike" kern="0" cap="none" spc="0" normalizeH="0" baseline="0" noProof="0" dirty="0" err="1">
+                <a:ln>
+                  <a:noFill/>
+                </a:ln>
+                <a:solidFill>
+                  <a:srgbClr val="000000"/>
+                </a:solidFill>
+                <a:effectLst/>
+                <a:uLnTx/>
+                <a:uFillTx/>
+              </a:rPr>
+              <a:t>the</a:t>
+            </a:r>
+            <a:r>
+              <a:rPr kumimoji="0" lang="de-DE" sz="1200" i="0" u="none" strike="noStrike" kern="0" cap="none" spc="0" normalizeH="0" baseline="0" noProof="0" dirty="0">
+                <a:ln>
+                  <a:noFill/>
+                </a:ln>
+                <a:solidFill>
+                  <a:srgbClr val="000000"/>
+                </a:solidFill>
+                <a:effectLst/>
+                <a:uLnTx/>
+                <a:uFillTx/>
+              </a:rPr>
+              <a:t> </a:t>
+            </a:r>
+            <a:r>
+              <a:rPr kumimoji="0" lang="de-DE" sz="1200" i="0" u="none" strike="noStrike" kern="0" cap="none" spc="0" normalizeH="0" baseline="0" noProof="0" dirty="0" err="1">
+                <a:ln>
+                  <a:noFill/>
+                </a:ln>
+                <a:solidFill>
+                  <a:srgbClr val="000000"/>
+                </a:solidFill>
+                <a:effectLst/>
+                <a:uLnTx/>
+                <a:uFillTx/>
+              </a:rPr>
+              <a:t>language</a:t>
+            </a:r>
+            <a:r>
+              <a:rPr kumimoji="0" lang="de-DE" sz="1200" i="0" u="none" strike="noStrike" kern="0" cap="none" spc="0" normalizeH="0" baseline="0" noProof="0" dirty="0">
+                <a:ln>
+                  <a:noFill/>
+                </a:ln>
+                <a:solidFill>
+                  <a:srgbClr val="000000"/>
+                </a:solidFill>
+                <a:effectLst/>
+                <a:uLnTx/>
+                <a:uFillTx/>
+              </a:rPr>
+              <a:t> </a:t>
+            </a:r>
+            <a:r>
+              <a:rPr kumimoji="0" lang="de-DE" sz="1200" i="0" u="none" strike="noStrike" kern="0" cap="none" spc="0" normalizeH="0" baseline="0" noProof="0" dirty="0" err="1">
+                <a:ln>
+                  <a:noFill/>
+                </a:ln>
+                <a:solidFill>
+                  <a:srgbClr val="000000"/>
+                </a:solidFill>
+                <a:effectLst/>
+                <a:uLnTx/>
+                <a:uFillTx/>
+              </a:rPr>
+              <a:t>elements</a:t>
+            </a:r>
+            <a:r>
+              <a:rPr kumimoji="0" lang="de-DE" sz="1200" i="0" u="none" strike="noStrike" kern="0" cap="none" spc="0" normalizeH="0" baseline="0" noProof="0" dirty="0">
+                <a:ln>
+                  <a:noFill/>
+                </a:ln>
+                <a:solidFill>
+                  <a:srgbClr val="000000"/>
+                </a:solidFill>
+                <a:effectLst/>
+                <a:uLnTx/>
+                <a:uFillTx/>
+              </a:rPr>
+              <a:t> </a:t>
+            </a:r>
+            <a:r>
+              <a:rPr kumimoji="0" lang="de-DE" sz="1200" i="0" u="none" strike="noStrike" kern="0" cap="none" spc="0" normalizeH="0" baseline="0" noProof="0" dirty="0" err="1">
+                <a:ln>
+                  <a:noFill/>
+                </a:ln>
+                <a:solidFill>
+                  <a:srgbClr val="000000"/>
+                </a:solidFill>
+                <a:effectLst/>
+                <a:uLnTx/>
+                <a:uFillTx/>
+              </a:rPr>
+              <a:t>have</a:t>
+            </a:r>
+            <a:r>
+              <a:rPr kumimoji="0" lang="de-DE" sz="1200" i="0" u="none" strike="noStrike" kern="0" cap="none" spc="0" normalizeH="0" baseline="0" noProof="0" dirty="0">
+                <a:ln>
+                  <a:noFill/>
+                </a:ln>
+                <a:solidFill>
+                  <a:srgbClr val="000000"/>
+                </a:solidFill>
+                <a:effectLst/>
+                <a:uLnTx/>
+                <a:uFillTx/>
+              </a:rPr>
+              <a:t> </a:t>
+            </a:r>
+            <a:r>
+              <a:rPr kumimoji="0" lang="de-DE" sz="1200" i="0" u="none" strike="noStrike" kern="0" cap="none" spc="0" normalizeH="0" baseline="0" noProof="0" dirty="0" err="1">
+                <a:ln>
+                  <a:noFill/>
+                </a:ln>
+                <a:solidFill>
+                  <a:srgbClr val="000000"/>
+                </a:solidFill>
+                <a:effectLst/>
+                <a:uLnTx/>
+                <a:uFillTx/>
+              </a:rPr>
+              <a:t>been</a:t>
+            </a:r>
+            <a:r>
+              <a:rPr kumimoji="0" lang="de-DE" sz="1200" i="0" u="none" strike="noStrike" kern="0" cap="none" spc="0" normalizeH="0" baseline="0" noProof="0" dirty="0">
+                <a:ln>
+                  <a:noFill/>
+                </a:ln>
+                <a:solidFill>
+                  <a:srgbClr val="000000"/>
+                </a:solidFill>
+                <a:effectLst/>
+                <a:uLnTx/>
+                <a:uFillTx/>
+              </a:rPr>
+              <a:t> </a:t>
+            </a:r>
+            <a:r>
+              <a:rPr kumimoji="0" lang="de-DE" sz="1200" i="0" u="none" strike="noStrike" kern="0" cap="none" spc="0" normalizeH="0" baseline="0" noProof="0" dirty="0" err="1">
+                <a:ln>
+                  <a:noFill/>
+                </a:ln>
+                <a:solidFill>
+                  <a:srgbClr val="000000"/>
+                </a:solidFill>
+                <a:effectLst/>
+                <a:uLnTx/>
+                <a:uFillTx/>
+              </a:rPr>
+              <a:t>reworked</a:t>
+            </a:r>
+            <a:r>
+              <a:rPr kumimoji="0" lang="de-DE" sz="1200" i="0" u="none" strike="noStrike" kern="0" cap="none" spc="0" normalizeH="0" baseline="0" noProof="0" dirty="0">
+                <a:ln>
+                  <a:noFill/>
+                </a:ln>
+                <a:solidFill>
+                  <a:srgbClr val="000000"/>
+                </a:solidFill>
+                <a:effectLst/>
+                <a:uLnTx/>
+                <a:uFillTx/>
+              </a:rPr>
+              <a:t>. </a:t>
+            </a:r>
+            <a:r>
+              <a:rPr kumimoji="0" lang="de-DE" sz="1200" i="0" u="none" strike="noStrike" kern="0" cap="none" spc="0" normalizeH="0" baseline="0" noProof="0" dirty="0" err="1">
+                <a:ln>
+                  <a:noFill/>
+                </a:ln>
+                <a:solidFill>
+                  <a:srgbClr val="000000"/>
+                </a:solidFill>
+                <a:effectLst/>
+                <a:uLnTx/>
+                <a:uFillTx/>
+              </a:rPr>
+              <a:t>Some</a:t>
+            </a:r>
+            <a:r>
+              <a:rPr kumimoji="0" lang="de-DE" sz="1200" i="0" u="none" strike="noStrike" kern="0" cap="none" spc="0" normalizeH="0" baseline="0" noProof="0" dirty="0">
+                <a:ln>
+                  <a:noFill/>
+                </a:ln>
+                <a:solidFill>
+                  <a:srgbClr val="000000"/>
+                </a:solidFill>
+                <a:effectLst/>
+                <a:uLnTx/>
+                <a:uFillTx/>
+              </a:rPr>
+              <a:t> </a:t>
+            </a:r>
+            <a:r>
+              <a:rPr kumimoji="0" lang="de-DE" sz="1200" i="0" u="none" strike="noStrike" kern="0" cap="none" spc="0" normalizeH="0" baseline="0" noProof="0" dirty="0" err="1">
+                <a:ln>
+                  <a:noFill/>
+                </a:ln>
+                <a:solidFill>
+                  <a:srgbClr val="000000"/>
+                </a:solidFill>
+                <a:effectLst/>
+                <a:uLnTx/>
+                <a:uFillTx/>
+              </a:rPr>
+              <a:t>of</a:t>
+            </a:r>
+            <a:r>
+              <a:rPr kumimoji="0" lang="de-DE" sz="1200" i="0" u="none" strike="noStrike" kern="0" cap="none" spc="0" normalizeH="0" baseline="0" noProof="0" dirty="0">
+                <a:ln>
+                  <a:noFill/>
+                </a:ln>
+                <a:solidFill>
+                  <a:srgbClr val="000000"/>
+                </a:solidFill>
+                <a:effectLst/>
+                <a:uLnTx/>
+                <a:uFillTx/>
+              </a:rPr>
+              <a:t> </a:t>
+            </a:r>
+            <a:r>
+              <a:rPr kumimoji="0" lang="de-DE" sz="1200" i="0" u="none" strike="noStrike" kern="0" cap="none" spc="0" normalizeH="0" baseline="0" noProof="0" dirty="0" err="1">
+                <a:ln>
+                  <a:noFill/>
+                </a:ln>
+                <a:solidFill>
+                  <a:srgbClr val="000000"/>
+                </a:solidFill>
+                <a:effectLst/>
+                <a:uLnTx/>
+                <a:uFillTx/>
+              </a:rPr>
+              <a:t>them</a:t>
+            </a:r>
+            <a:r>
+              <a:rPr kumimoji="0" lang="de-DE" sz="1200" i="0" u="none" strike="noStrike" kern="0" cap="none" spc="0" normalizeH="0" baseline="0" noProof="0" dirty="0">
+                <a:ln>
+                  <a:noFill/>
+                </a:ln>
+                <a:solidFill>
+                  <a:srgbClr val="000000"/>
+                </a:solidFill>
+                <a:effectLst/>
+                <a:uLnTx/>
+                <a:uFillTx/>
+              </a:rPr>
+              <a:t> </a:t>
+            </a:r>
+            <a:r>
+              <a:rPr kumimoji="0" lang="de-DE" sz="1200" i="0" u="none" strike="noStrike" kern="0" cap="none" spc="0" normalizeH="0" baseline="0" noProof="0" dirty="0" err="1">
+                <a:ln>
+                  <a:noFill/>
+                </a:ln>
+                <a:solidFill>
+                  <a:srgbClr val="000000"/>
+                </a:solidFill>
+                <a:effectLst/>
+                <a:uLnTx/>
+                <a:uFillTx/>
+              </a:rPr>
+              <a:t>are</a:t>
+            </a:r>
+            <a:r>
+              <a:rPr kumimoji="0" lang="de-DE" sz="1200" i="0" u="none" strike="noStrike" kern="0" cap="none" spc="0" normalizeH="0" baseline="0" noProof="0" dirty="0">
+                <a:ln>
+                  <a:noFill/>
+                </a:ln>
+                <a:solidFill>
+                  <a:srgbClr val="000000"/>
+                </a:solidFill>
+                <a:effectLst/>
+                <a:uLnTx/>
+                <a:uFillTx/>
+              </a:rPr>
+              <a:t> </a:t>
+            </a:r>
+            <a:r>
+              <a:rPr kumimoji="0" lang="de-DE" sz="1200" i="0" u="none" strike="noStrike" kern="0" cap="none" spc="0" normalizeH="0" baseline="0" noProof="0" dirty="0" err="1">
+                <a:ln>
+                  <a:noFill/>
+                </a:ln>
+                <a:solidFill>
+                  <a:srgbClr val="000000"/>
+                </a:solidFill>
+                <a:effectLst/>
+                <a:uLnTx/>
+                <a:uFillTx/>
+              </a:rPr>
+              <a:t>deprecated</a:t>
+            </a:r>
+            <a:r>
+              <a:rPr kumimoji="0" lang="de-DE" sz="1200" i="0" u="none" strike="noStrike" kern="0" cap="none" spc="0" normalizeH="0" baseline="0" noProof="0" dirty="0">
+                <a:ln>
+                  <a:noFill/>
+                </a:ln>
+                <a:solidFill>
+                  <a:srgbClr val="000000"/>
+                </a:solidFill>
+                <a:effectLst/>
+                <a:uLnTx/>
+                <a:uFillTx/>
+              </a:rPr>
+              <a:t> </a:t>
+            </a:r>
+            <a:r>
+              <a:rPr kumimoji="0" lang="de-DE" sz="1200" i="0" u="none" strike="noStrike" kern="0" cap="none" spc="0" normalizeH="0" baseline="0" noProof="0" dirty="0" err="1">
+                <a:ln>
+                  <a:noFill/>
+                </a:ln>
+                <a:solidFill>
+                  <a:srgbClr val="000000"/>
+                </a:solidFill>
+                <a:effectLst/>
+                <a:uLnTx/>
+                <a:uFillTx/>
+              </a:rPr>
+              <a:t>now</a:t>
+            </a:r>
+            <a:r>
+              <a:rPr kumimoji="0" lang="de-DE" sz="1200" i="0" u="none" strike="noStrike" kern="0" cap="none" spc="0" normalizeH="0" baseline="0" noProof="0" dirty="0">
+                <a:ln>
+                  <a:noFill/>
+                </a:ln>
+                <a:solidFill>
+                  <a:srgbClr val="000000"/>
+                </a:solidFill>
+                <a:effectLst/>
+                <a:uLnTx/>
+                <a:uFillTx/>
+              </a:rPr>
+              <a:t>. </a:t>
+            </a:r>
+            <a:r>
+              <a:rPr kumimoji="0" lang="de-DE" sz="1200" i="0" u="none" strike="noStrike" kern="0" cap="none" spc="0" normalizeH="0" baseline="0" noProof="0" dirty="0" err="1">
+                <a:ln>
+                  <a:noFill/>
+                </a:ln>
+                <a:solidFill>
+                  <a:srgbClr val="000000"/>
+                </a:solidFill>
+                <a:effectLst/>
+                <a:uLnTx/>
+                <a:uFillTx/>
+              </a:rPr>
+              <a:t>To</a:t>
+            </a:r>
+            <a:r>
+              <a:rPr kumimoji="0" lang="de-DE" sz="1200" i="0" u="none" strike="noStrike" kern="0" cap="none" spc="0" normalizeH="0" baseline="0" noProof="0" dirty="0">
+                <a:ln>
+                  <a:noFill/>
+                </a:ln>
+                <a:solidFill>
+                  <a:srgbClr val="000000"/>
+                </a:solidFill>
+                <a:effectLst/>
+                <a:uLnTx/>
+                <a:uFillTx/>
+              </a:rPr>
+              <a:t> </a:t>
+            </a:r>
+            <a:r>
+              <a:rPr kumimoji="0" lang="de-DE" sz="1200" i="0" u="none" strike="noStrike" kern="0" cap="none" spc="0" normalizeH="0" baseline="0" noProof="0" dirty="0" err="1">
+                <a:ln>
+                  <a:noFill/>
+                </a:ln>
+                <a:solidFill>
+                  <a:srgbClr val="000000"/>
+                </a:solidFill>
+                <a:effectLst/>
+                <a:uLnTx/>
+                <a:uFillTx/>
+              </a:rPr>
+              <a:t>ensure</a:t>
+            </a:r>
+            <a:r>
+              <a:rPr kumimoji="0" lang="de-DE" sz="1200" i="0" u="none" strike="noStrike" kern="0" cap="none" spc="0" normalizeH="0" baseline="0" noProof="0" dirty="0">
+                <a:ln>
+                  <a:noFill/>
+                </a:ln>
+                <a:solidFill>
+                  <a:srgbClr val="000000"/>
+                </a:solidFill>
+                <a:effectLst/>
+                <a:uLnTx/>
+                <a:uFillTx/>
+              </a:rPr>
+              <a:t> </a:t>
+            </a:r>
+            <a:r>
+              <a:rPr kumimoji="0" lang="de-DE" sz="1200" i="0" u="none" strike="noStrike" kern="0" cap="none" spc="0" normalizeH="0" baseline="0" noProof="0" dirty="0" err="1">
+                <a:ln>
+                  <a:noFill/>
+                </a:ln>
+                <a:solidFill>
+                  <a:srgbClr val="000000"/>
+                </a:solidFill>
+                <a:effectLst/>
+                <a:uLnTx/>
+                <a:uFillTx/>
+              </a:rPr>
+              <a:t>downward</a:t>
+            </a:r>
+            <a:r>
+              <a:rPr kumimoji="0" lang="de-DE" sz="1200" i="0" u="none" strike="noStrike" kern="0" cap="none" spc="0" normalizeH="0" baseline="0" noProof="0" dirty="0">
+                <a:ln>
+                  <a:noFill/>
+                </a:ln>
+                <a:solidFill>
+                  <a:srgbClr val="000000"/>
+                </a:solidFill>
+                <a:effectLst/>
+                <a:uLnTx/>
+                <a:uFillTx/>
+              </a:rPr>
+              <a:t> </a:t>
+            </a:r>
+            <a:r>
+              <a:rPr kumimoji="0" lang="de-DE" sz="1200" i="0" u="none" strike="noStrike" kern="0" cap="none" spc="0" normalizeH="0" baseline="0" noProof="0" dirty="0" err="1">
+                <a:ln>
+                  <a:noFill/>
+                </a:ln>
+                <a:solidFill>
+                  <a:srgbClr val="000000"/>
+                </a:solidFill>
+                <a:effectLst/>
+                <a:uLnTx/>
+                <a:uFillTx/>
+              </a:rPr>
+              <a:t>compatibility</a:t>
+            </a:r>
+            <a:r>
+              <a:rPr kumimoji="0" lang="de-DE" sz="1200" i="0" u="none" strike="noStrike" kern="0" cap="none" spc="0" normalizeH="0" baseline="0" noProof="0" dirty="0">
+                <a:ln>
+                  <a:noFill/>
+                </a:ln>
+                <a:solidFill>
+                  <a:srgbClr val="000000"/>
+                </a:solidFill>
+                <a:effectLst/>
+                <a:uLnTx/>
+                <a:uFillTx/>
+              </a:rPr>
+              <a:t>, </a:t>
+            </a:r>
+            <a:r>
+              <a:rPr kumimoji="0" lang="de-DE" sz="1200" i="0" u="none" strike="noStrike" kern="0" cap="none" spc="0" normalizeH="0" baseline="0" noProof="0" dirty="0" err="1">
+                <a:ln>
+                  <a:noFill/>
+                </a:ln>
+                <a:solidFill>
+                  <a:srgbClr val="000000"/>
+                </a:solidFill>
+                <a:effectLst/>
+                <a:uLnTx/>
+                <a:uFillTx/>
+              </a:rPr>
+              <a:t>they</a:t>
+            </a:r>
+            <a:r>
+              <a:rPr kumimoji="0" lang="de-DE" sz="1200" i="0" u="none" strike="noStrike" kern="0" cap="none" spc="0" normalizeH="0" baseline="0" noProof="0" dirty="0">
+                <a:ln>
+                  <a:noFill/>
+                </a:ln>
+                <a:solidFill>
+                  <a:srgbClr val="000000"/>
+                </a:solidFill>
+                <a:effectLst/>
+                <a:uLnTx/>
+                <a:uFillTx/>
+              </a:rPr>
+              <a:t> </a:t>
+            </a:r>
+            <a:r>
+              <a:rPr kumimoji="0" lang="de-DE" sz="1200" i="0" u="none" strike="noStrike" kern="0" cap="none" spc="0" normalizeH="0" baseline="0" noProof="0" dirty="0" err="1">
+                <a:ln>
+                  <a:noFill/>
+                </a:ln>
+                <a:solidFill>
+                  <a:srgbClr val="000000"/>
+                </a:solidFill>
+                <a:effectLst/>
+                <a:uLnTx/>
+                <a:uFillTx/>
+              </a:rPr>
+              <a:t>are</a:t>
+            </a:r>
+            <a:r>
+              <a:rPr kumimoji="0" lang="de-DE" sz="1200" i="0" u="none" strike="noStrike" kern="0" cap="none" spc="0" normalizeH="0" baseline="0" noProof="0" dirty="0">
+                <a:ln>
+                  <a:noFill/>
+                </a:ln>
+                <a:solidFill>
+                  <a:srgbClr val="000000"/>
+                </a:solidFill>
+                <a:effectLst/>
+                <a:uLnTx/>
+                <a:uFillTx/>
+              </a:rPr>
+              <a:t> </a:t>
+            </a:r>
+            <a:r>
+              <a:rPr kumimoji="0" lang="de-DE" sz="1200" i="0" u="none" strike="noStrike" kern="0" cap="none" spc="0" normalizeH="0" baseline="0" noProof="0" dirty="0" err="1">
+                <a:ln>
+                  <a:noFill/>
+                </a:ln>
+                <a:solidFill>
+                  <a:srgbClr val="000000"/>
+                </a:solidFill>
+                <a:effectLst/>
+                <a:uLnTx/>
+                <a:uFillTx/>
+              </a:rPr>
+              <a:t>mapped</a:t>
+            </a:r>
+            <a:r>
+              <a:rPr kumimoji="0" lang="de-DE" sz="1200" i="0" u="none" strike="noStrike" kern="0" cap="none" spc="0" normalizeH="0" baseline="0" noProof="0" dirty="0">
+                <a:ln>
+                  <a:noFill/>
+                </a:ln>
+                <a:solidFill>
+                  <a:srgbClr val="000000"/>
+                </a:solidFill>
+                <a:effectLst/>
+                <a:uLnTx/>
+                <a:uFillTx/>
+              </a:rPr>
+              <a:t> </a:t>
+            </a:r>
+            <a:r>
+              <a:rPr kumimoji="0" lang="de-DE" sz="1200" i="0" u="none" strike="noStrike" kern="0" cap="none" spc="0" normalizeH="0" baseline="0" noProof="0" dirty="0" err="1">
+                <a:ln>
+                  <a:noFill/>
+                </a:ln>
+                <a:solidFill>
+                  <a:srgbClr val="000000"/>
+                </a:solidFill>
+                <a:effectLst/>
+                <a:uLnTx/>
+                <a:uFillTx/>
+              </a:rPr>
+              <a:t>to</a:t>
+            </a:r>
+            <a:r>
+              <a:rPr kumimoji="0" lang="de-DE" sz="1200" i="0" u="none" strike="noStrike" kern="0" cap="none" spc="0" normalizeH="0" baseline="0" noProof="0" dirty="0">
+                <a:ln>
+                  <a:noFill/>
+                </a:ln>
+                <a:solidFill>
+                  <a:srgbClr val="000000"/>
+                </a:solidFill>
+                <a:effectLst/>
+                <a:uLnTx/>
+                <a:uFillTx/>
+              </a:rPr>
+              <a:t> </a:t>
+            </a:r>
+            <a:r>
+              <a:rPr kumimoji="0" lang="de-DE" sz="1200" i="0" u="none" strike="noStrike" kern="0" cap="none" spc="0" normalizeH="0" baseline="0" noProof="0" dirty="0" err="1">
+                <a:ln>
+                  <a:noFill/>
+                </a:ln>
+                <a:solidFill>
+                  <a:srgbClr val="000000"/>
+                </a:solidFill>
+                <a:effectLst/>
+                <a:uLnTx/>
+                <a:uFillTx/>
+              </a:rPr>
+              <a:t>new</a:t>
+            </a:r>
+            <a:r>
+              <a:rPr kumimoji="0" lang="de-DE" sz="1200" i="0" u="none" strike="noStrike" kern="0" cap="none" spc="0" normalizeH="0" baseline="0" noProof="0" dirty="0">
+                <a:ln>
+                  <a:noFill/>
+                </a:ln>
+                <a:solidFill>
+                  <a:srgbClr val="000000"/>
+                </a:solidFill>
+                <a:effectLst/>
+                <a:uLnTx/>
+                <a:uFillTx/>
+              </a:rPr>
+              <a:t> </a:t>
+            </a:r>
+            <a:r>
+              <a:rPr kumimoji="0" lang="de-DE" sz="1200" i="0" u="none" strike="noStrike" kern="0" cap="none" spc="0" normalizeH="0" baseline="0" noProof="0" dirty="0" err="1">
+                <a:ln>
+                  <a:noFill/>
+                </a:ln>
+                <a:solidFill>
+                  <a:srgbClr val="000000"/>
+                </a:solidFill>
+                <a:effectLst/>
+                <a:uLnTx/>
+                <a:uFillTx/>
+              </a:rPr>
+              <a:t>ones</a:t>
+            </a:r>
+            <a:r>
+              <a:rPr kumimoji="0" lang="de-DE" sz="1200" i="0" u="none" strike="noStrike" kern="0" cap="none" spc="0" normalizeH="0" baseline="0" noProof="0" dirty="0">
+                <a:ln>
+                  <a:noFill/>
+                </a:ln>
+                <a:solidFill>
+                  <a:srgbClr val="000000"/>
+                </a:solidFill>
+                <a:effectLst/>
+                <a:uLnTx/>
+                <a:uFillTx/>
+              </a:rPr>
+              <a:t>.</a:t>
+            </a:r>
+          </a:p>
+        </p:txBody>
+      </p:sp>
+      <p:graphicFrame>
+        <p:nvGraphicFramePr>
+          <p:cNvPr id="5" name="Tabelle 4">
+            <a:extLst>
+              <a:ext uri="{FF2B5EF4-FFF2-40B4-BE49-F238E27FC236}">
+                <a16:creationId xmlns:a16="http://schemas.microsoft.com/office/drawing/2014/main" id="{2EE17DCA-E182-C525-F371-A8547C399F1E}"/>
+              </a:ext>
+            </a:extLst>
+          </p:cNvPr>
+          <p:cNvGraphicFramePr>
+            <a:graphicFrameLocks noGrp="1"/>
+          </p:cNvGraphicFramePr>
+          <p:nvPr>
+            <p:extLst>
+              <p:ext uri="{D42A27DB-BD31-4B8C-83A1-F6EECF244321}">
+                <p14:modId xmlns:p14="http://schemas.microsoft.com/office/powerpoint/2010/main" val="2164345178"/>
+              </p:ext>
+            </p:extLst>
+          </p:nvPr>
+        </p:nvGraphicFramePr>
+        <p:xfrm>
+          <a:off x="259200" y="1233792"/>
+          <a:ext cx="10283832" cy="4190483"/>
+        </p:xfrm>
+        <a:graphic>
+          <a:graphicData uri="http://schemas.openxmlformats.org/drawingml/2006/table">
+            <a:tbl>
+              <a:tblPr firstRow="1" bandRow="1">
+                <a:tableStyleId>{F5AB1C69-6EDB-4FF4-983F-18BD219EF322}</a:tableStyleId>
+              </a:tblPr>
+              <a:tblGrid>
+                <a:gridCol w="3645288">
+                  <a:extLst>
+                    <a:ext uri="{9D8B030D-6E8A-4147-A177-3AD203B41FA5}">
+                      <a16:colId xmlns:a16="http://schemas.microsoft.com/office/drawing/2014/main" val="43910445"/>
+                    </a:ext>
+                  </a:extLst>
+                </a:gridCol>
+                <a:gridCol w="3639312">
+                  <a:extLst>
+                    <a:ext uri="{9D8B030D-6E8A-4147-A177-3AD203B41FA5}">
+                      <a16:colId xmlns:a16="http://schemas.microsoft.com/office/drawing/2014/main" val="3741258493"/>
+                    </a:ext>
+                  </a:extLst>
+                </a:gridCol>
+                <a:gridCol w="2999232">
+                  <a:extLst>
+                    <a:ext uri="{9D8B030D-6E8A-4147-A177-3AD203B41FA5}">
+                      <a16:colId xmlns:a16="http://schemas.microsoft.com/office/drawing/2014/main" val="2562324463"/>
+                    </a:ext>
+                  </a:extLst>
+                </a:gridCol>
+              </a:tblGrid>
+              <a:tr h="376203">
+                <a:tc>
+                  <a:txBody>
+                    <a:bodyPr/>
+                    <a:lstStyle/>
+                    <a:p>
+                      <a:r>
+                        <a:rPr lang="de-DE" dirty="0">
+                          <a:solidFill>
+                            <a:schemeClr val="tx1"/>
+                          </a:solidFill>
+                        </a:rPr>
+                        <a:t>RST</a:t>
+                      </a:r>
+                    </a:p>
+                  </a:txBody>
+                  <a:tcPr/>
+                </a:tc>
+                <a:tc>
+                  <a:txBody>
+                    <a:bodyPr/>
+                    <a:lstStyle/>
+                    <a:p>
+                      <a:r>
+                        <a:rPr lang="de-DE" dirty="0" err="1">
+                          <a:solidFill>
+                            <a:schemeClr val="tx1"/>
+                          </a:solidFill>
+                        </a:rPr>
+                        <a:t>LaTeX</a:t>
+                      </a:r>
+                      <a:r>
+                        <a:rPr lang="de-DE" dirty="0">
+                          <a:solidFill>
+                            <a:schemeClr val="tx1"/>
+                          </a:solidFill>
+                        </a:rPr>
+                        <a:t>/PDF</a:t>
+                      </a:r>
+                    </a:p>
+                  </a:txBody>
+                  <a:tcPr/>
+                </a:tc>
+                <a:tc>
+                  <a:txBody>
+                    <a:bodyPr/>
+                    <a:lstStyle/>
+                    <a:p>
+                      <a:r>
+                        <a:rPr lang="de-DE" dirty="0">
+                          <a:solidFill>
+                            <a:schemeClr val="tx1"/>
+                          </a:solidFill>
+                        </a:rPr>
+                        <a:t>HTML</a:t>
+                      </a:r>
+                    </a:p>
+                  </a:txBody>
+                  <a:tcPr/>
+                </a:tc>
+                <a:extLst>
+                  <a:ext uri="{0D108BD9-81ED-4DB2-BD59-A6C34878D82A}">
+                    <a16:rowId xmlns:a16="http://schemas.microsoft.com/office/drawing/2014/main" val="3297251498"/>
+                  </a:ext>
+                </a:extLst>
+              </a:tr>
+              <a:tr h="381428">
+                <a:tc>
+                  <a:txBody>
+                    <a:bodyPr/>
+                    <a:lstStyle/>
+                    <a:p>
+                      <a:r>
+                        <a:rPr lang="de-DE" dirty="0">
+                          <a:latin typeface="72 Monospace" panose="020B0509030603020204" pitchFamily="49" charset="0"/>
+                          <a:cs typeface="72 Monospace" panose="020B0509030603020204" pitchFamily="49" charset="0"/>
+                        </a:rPr>
+                        <a:t>/NL    </a:t>
+                      </a:r>
+                      <a:r>
+                        <a:rPr lang="de-DE" dirty="0">
+                          <a:latin typeface="+mn-lt"/>
+                          <a:cs typeface="72 Monospace" panose="020B0509030603020204" pitchFamily="49" charset="0"/>
+                        </a:rPr>
+                        <a:t>(</a:t>
+                      </a:r>
+                      <a:r>
+                        <a:rPr lang="de-DE" i="1" dirty="0" err="1">
+                          <a:latin typeface="+mn-lt"/>
+                          <a:cs typeface="72 Monospace" panose="020B0509030603020204" pitchFamily="49" charset="0"/>
+                        </a:rPr>
+                        <a:t>newline</a:t>
+                      </a:r>
+                      <a:r>
+                        <a:rPr lang="de-DE" dirty="0">
+                          <a:latin typeface="+mn-lt"/>
+                          <a:cs typeface="72 Monospace" panose="020B0509030603020204" pitchFamily="49" charset="0"/>
+                        </a:rPr>
+                        <a:t>)</a:t>
+                      </a:r>
+                      <a:endParaRPr lang="de-DE" dirty="0">
+                        <a:latin typeface="72 Monospace" panose="020B0509030603020204" pitchFamily="49" charset="0"/>
+                        <a:cs typeface="72 Monospace" panose="020B0509030603020204" pitchFamily="49" charset="0"/>
+                      </a:endParaRPr>
+                    </a:p>
+                  </a:txBody>
+                  <a:tcPr/>
+                </a:tc>
+                <a:tc>
+                  <a:txBody>
+                    <a:bodyPr/>
+                    <a:lstStyle/>
+                    <a:p>
+                      <a:r>
+                        <a:rPr lang="de-DE" i="0" dirty="0">
+                          <a:solidFill>
+                            <a:schemeClr val="tx1"/>
+                          </a:solidFill>
+                          <a:latin typeface="72 Monospace" panose="020B0509030603020204" pitchFamily="49" charset="0"/>
+                          <a:cs typeface="72 Monospace" panose="020B0509030603020204" pitchFamily="49" charset="0"/>
+                        </a:rPr>
+                        <a:t>\</a:t>
+                      </a:r>
+                      <a:r>
+                        <a:rPr lang="de-DE" i="0" dirty="0" err="1">
+                          <a:solidFill>
+                            <a:schemeClr val="tx1"/>
+                          </a:solidFill>
+                          <a:latin typeface="72 Monospace" panose="020B0509030603020204" pitchFamily="49" charset="0"/>
+                          <a:cs typeface="72 Monospace" panose="020B0509030603020204" pitchFamily="49" charset="0"/>
+                        </a:rPr>
+                        <a:t>newline</a:t>
+                      </a:r>
+                      <a:endParaRPr lang="de-DE" i="0" dirty="0">
+                        <a:solidFill>
+                          <a:schemeClr val="tx1"/>
+                        </a:solidFill>
+                        <a:latin typeface="72 Monospace" panose="020B0509030603020204" pitchFamily="49" charset="0"/>
+                        <a:cs typeface="72 Monospace" panose="020B0509030603020204" pitchFamily="49" charset="0"/>
+                      </a:endParaRPr>
+                    </a:p>
+                  </a:txBody>
+                  <a:tcPr/>
+                </a:tc>
+                <a:tc>
+                  <a:txBody>
+                    <a:bodyPr/>
+                    <a:lstStyle/>
+                    <a:p>
+                      <a:r>
+                        <a:rPr lang="de-DE" dirty="0"/>
+                        <a:t>&lt;</a:t>
+                      </a:r>
+                      <a:r>
+                        <a:rPr lang="de-DE" dirty="0" err="1"/>
+                        <a:t>br</a:t>
+                      </a:r>
+                      <a:r>
+                        <a:rPr lang="de-DE" dirty="0"/>
+                        <a:t>&gt;</a:t>
+                      </a:r>
+                    </a:p>
+                  </a:txBody>
+                  <a:tcPr/>
+                </a:tc>
+                <a:extLst>
+                  <a:ext uri="{0D108BD9-81ED-4DB2-BD59-A6C34878D82A}">
+                    <a16:rowId xmlns:a16="http://schemas.microsoft.com/office/drawing/2014/main" val="3909443894"/>
+                  </a:ext>
+                </a:extLst>
+              </a:tr>
+              <a:tr h="381428">
+                <a:tc>
+                  <a:txBody>
+                    <a:bodyPr/>
+                    <a:lstStyle/>
+                    <a:p>
+                      <a:r>
+                        <a:rPr lang="de-DE" dirty="0">
+                          <a:latin typeface="72 Monospace" panose="020B0509030603020204" pitchFamily="49" charset="0"/>
+                          <a:cs typeface="72 Monospace" panose="020B0509030603020204" pitchFamily="49" charset="0"/>
+                        </a:rPr>
+                        <a:t>/NP    </a:t>
+                      </a:r>
+                      <a:r>
+                        <a:rPr lang="de-DE" dirty="0">
+                          <a:latin typeface="+mn-lt"/>
+                          <a:cs typeface="72 Monospace" panose="020B0509030603020204" pitchFamily="49" charset="0"/>
+                        </a:rPr>
+                        <a:t>(</a:t>
+                      </a:r>
+                      <a:r>
+                        <a:rPr lang="de-DE" i="1" dirty="0" err="1">
+                          <a:latin typeface="+mn-lt"/>
+                          <a:cs typeface="72 Monospace" panose="020B0509030603020204" pitchFamily="49" charset="0"/>
+                        </a:rPr>
+                        <a:t>newpage</a:t>
+                      </a:r>
+                      <a:r>
+                        <a:rPr lang="de-DE" dirty="0">
+                          <a:latin typeface="+mn-lt"/>
+                          <a:cs typeface="72 Monospace" panose="020B0509030603020204" pitchFamily="49" charset="0"/>
+                        </a:rPr>
+                        <a:t>)</a:t>
+                      </a:r>
+                      <a:endParaRPr lang="de-DE" dirty="0">
+                        <a:latin typeface="72 Monospace" panose="020B0509030603020204" pitchFamily="49" charset="0"/>
+                        <a:cs typeface="72 Monospace" panose="020B0509030603020204" pitchFamily="49" charset="0"/>
+                      </a:endParaRPr>
+                    </a:p>
+                  </a:txBody>
+                  <a:tcPr/>
+                </a:tc>
+                <a:tc>
+                  <a:txBody>
+                    <a:bodyPr/>
+                    <a:lstStyle/>
+                    <a:p>
+                      <a:r>
+                        <a:rPr lang="de-DE" i="0" dirty="0">
+                          <a:solidFill>
+                            <a:schemeClr val="tx1"/>
+                          </a:solidFill>
+                          <a:latin typeface="72 Monospace" panose="020B0509030603020204" pitchFamily="49" charset="0"/>
+                          <a:cs typeface="72 Monospace" panose="020B0509030603020204" pitchFamily="49" charset="0"/>
+                        </a:rPr>
+                        <a:t>\</a:t>
+                      </a:r>
+                      <a:r>
+                        <a:rPr lang="de-DE" i="0" dirty="0" err="1">
+                          <a:solidFill>
+                            <a:schemeClr val="tx1"/>
+                          </a:solidFill>
+                          <a:latin typeface="72 Monospace" panose="020B0509030603020204" pitchFamily="49" charset="0"/>
+                          <a:cs typeface="72 Monospace" panose="020B0509030603020204" pitchFamily="49" charset="0"/>
+                        </a:rPr>
+                        <a:t>newpage</a:t>
+                      </a:r>
+                      <a:endParaRPr lang="de-DE" i="0" dirty="0">
+                        <a:solidFill>
+                          <a:schemeClr val="tx1"/>
+                        </a:solidFill>
+                        <a:latin typeface="72 Monospace" panose="020B0509030603020204" pitchFamily="49" charset="0"/>
+                        <a:cs typeface="72 Monospace" panose="020B0509030603020204" pitchFamily="49" charset="0"/>
+                      </a:endParaRPr>
+                    </a:p>
+                  </a:txBody>
+                  <a:tcPr/>
+                </a:tc>
+                <a:tc>
+                  <a:txBody>
+                    <a:bodyPr/>
+                    <a:lstStyle/>
+                    <a:p>
+                      <a:pPr marL="0" marR="0" lvl="0" indent="0" algn="l" defTabSz="914333" rtl="0" eaLnBrk="1" fontAlgn="auto" latinLnBrk="0" hangingPunct="1">
+                        <a:lnSpc>
+                          <a:spcPct val="100000"/>
+                        </a:lnSpc>
+                        <a:spcBef>
+                          <a:spcPts val="0"/>
+                        </a:spcBef>
+                        <a:spcAft>
+                          <a:spcPts val="0"/>
+                        </a:spcAft>
+                        <a:buClrTx/>
+                        <a:buSzTx/>
+                        <a:buFontTx/>
+                        <a:buNone/>
+                        <a:tabLst/>
+                        <a:defRPr/>
+                      </a:pPr>
+                      <a:r>
+                        <a:rPr lang="de-DE">
+                          <a:latin typeface="72 Monospace" panose="020B0509030603020204" pitchFamily="49" charset="0"/>
+                          <a:cs typeface="72 Monospace" panose="020B0509030603020204" pitchFamily="49" charset="0"/>
+                        </a:rPr>
+                        <a:t>""</a:t>
+                      </a:r>
+                      <a:endParaRPr lang="de-DE" dirty="0">
+                        <a:latin typeface="72 Monospace" panose="020B0509030603020204" pitchFamily="49" charset="0"/>
+                        <a:cs typeface="72 Monospace" panose="020B0509030603020204" pitchFamily="49" charset="0"/>
+                      </a:endParaRPr>
+                    </a:p>
+                  </a:txBody>
+                  <a:tcPr/>
+                </a:tc>
+                <a:extLst>
+                  <a:ext uri="{0D108BD9-81ED-4DB2-BD59-A6C34878D82A}">
+                    <a16:rowId xmlns:a16="http://schemas.microsoft.com/office/drawing/2014/main" val="3804488654"/>
+                  </a:ext>
+                </a:extLst>
+              </a:tr>
+              <a:tr h="381428">
+                <a:tc>
+                  <a:txBody>
+                    <a:bodyPr/>
+                    <a:lstStyle/>
+                    <a:p>
+                      <a:r>
+                        <a:rPr lang="de-DE" dirty="0">
+                          <a:latin typeface="72 Monospace" panose="020B0509030603020204" pitchFamily="49" charset="0"/>
+                          <a:cs typeface="72 Monospace" panose="020B0509030603020204" pitchFamily="49" charset="0"/>
+                        </a:rPr>
+                        <a:t>/VS    </a:t>
+                      </a:r>
+                      <a:r>
+                        <a:rPr lang="de-DE" dirty="0">
+                          <a:latin typeface="+mn-lt"/>
+                          <a:cs typeface="72 Monospace" panose="020B0509030603020204" pitchFamily="49" charset="0"/>
+                        </a:rPr>
+                        <a:t>(</a:t>
+                      </a:r>
+                      <a:r>
+                        <a:rPr lang="de-DE" i="1" dirty="0" err="1">
+                          <a:latin typeface="+mn-lt"/>
+                          <a:cs typeface="72 Monospace" panose="020B0509030603020204" pitchFamily="49" charset="0"/>
+                        </a:rPr>
+                        <a:t>vertical</a:t>
+                      </a:r>
+                      <a:r>
+                        <a:rPr lang="de-DE" i="1" dirty="0">
+                          <a:latin typeface="+mn-lt"/>
+                          <a:cs typeface="72 Monospace" panose="020B0509030603020204" pitchFamily="49" charset="0"/>
+                        </a:rPr>
+                        <a:t> </a:t>
+                      </a:r>
+                      <a:r>
+                        <a:rPr lang="de-DE" i="1" dirty="0" err="1">
+                          <a:latin typeface="+mn-lt"/>
+                          <a:cs typeface="72 Monospace" panose="020B0509030603020204" pitchFamily="49" charset="0"/>
+                        </a:rPr>
+                        <a:t>space</a:t>
+                      </a:r>
+                      <a:r>
+                        <a:rPr lang="de-DE" i="1" dirty="0">
+                          <a:latin typeface="+mn-lt"/>
+                          <a:cs typeface="72 Monospace" panose="020B0509030603020204" pitchFamily="49" charset="0"/>
+                        </a:rPr>
+                        <a:t> 1</a:t>
+                      </a:r>
+                      <a:r>
+                        <a:rPr lang="de-DE" dirty="0">
+                          <a:latin typeface="+mn-lt"/>
+                          <a:cs typeface="72 Monospace" panose="020B0509030603020204" pitchFamily="49" charset="0"/>
+                        </a:rPr>
+                        <a:t>)</a:t>
+                      </a:r>
+                      <a:endParaRPr lang="de-DE" dirty="0">
+                        <a:latin typeface="72 Monospace" panose="020B0509030603020204" pitchFamily="49" charset="0"/>
+                        <a:cs typeface="72 Monospace" panose="020B0509030603020204" pitchFamily="49" charset="0"/>
+                      </a:endParaRPr>
+                    </a:p>
+                  </a:txBody>
+                  <a:tcPr/>
+                </a:tc>
+                <a:tc>
+                  <a:txBody>
+                    <a:bodyPr/>
+                    <a:lstStyle/>
+                    <a:p>
+                      <a:pPr marL="0" marR="0" lvl="0" indent="0" algn="l" defTabSz="914333" rtl="0" eaLnBrk="1" fontAlgn="auto" latinLnBrk="0" hangingPunct="1">
+                        <a:lnSpc>
+                          <a:spcPct val="100000"/>
+                        </a:lnSpc>
+                        <a:spcBef>
+                          <a:spcPts val="0"/>
+                        </a:spcBef>
+                        <a:spcAft>
+                          <a:spcPts val="0"/>
+                        </a:spcAft>
+                        <a:buClrTx/>
+                        <a:buSzTx/>
+                        <a:buFontTx/>
+                        <a:buNone/>
+                        <a:tabLst/>
+                        <a:defRPr/>
+                      </a:pPr>
+                      <a:r>
+                        <a:rPr lang="de-DE" i="0" dirty="0">
+                          <a:solidFill>
+                            <a:schemeClr val="tx1"/>
+                          </a:solidFill>
+                          <a:latin typeface="72 Monospace" panose="020B0509030603020204" pitchFamily="49" charset="0"/>
+                          <a:cs typeface="72 Monospace" panose="020B0509030603020204" pitchFamily="49" charset="0"/>
+                        </a:rPr>
+                        <a:t>\</a:t>
+                      </a:r>
+                      <a:r>
+                        <a:rPr lang="de-DE" i="0" dirty="0" err="1">
+                          <a:solidFill>
+                            <a:schemeClr val="tx1"/>
+                          </a:solidFill>
+                          <a:latin typeface="72 Monospace" panose="020B0509030603020204" pitchFamily="49" charset="0"/>
+                          <a:cs typeface="72 Monospace" panose="020B0509030603020204" pitchFamily="49" charset="0"/>
+                        </a:rPr>
+                        <a:t>vspace</a:t>
+                      </a:r>
+                      <a:r>
+                        <a:rPr lang="de-DE" i="0" dirty="0">
+                          <a:solidFill>
+                            <a:schemeClr val="tx1"/>
+                          </a:solidFill>
+                          <a:latin typeface="72 Monospace" panose="020B0509030603020204" pitchFamily="49" charset="0"/>
+                          <a:cs typeface="72 Monospace" panose="020B0509030603020204" pitchFamily="49" charset="0"/>
+                        </a:rPr>
+                        <a:t>{1ex}</a:t>
+                      </a:r>
+                    </a:p>
+                  </a:txBody>
+                  <a:tcPr/>
+                </a:tc>
+                <a:tc>
+                  <a:txBody>
+                    <a:bodyPr/>
+                    <a:lstStyle/>
+                    <a:p>
+                      <a:pPr marL="0" marR="0" lvl="0" indent="0" algn="l" defTabSz="914333" rtl="0" eaLnBrk="1" fontAlgn="auto" latinLnBrk="0" hangingPunct="1">
+                        <a:lnSpc>
+                          <a:spcPct val="100000"/>
+                        </a:lnSpc>
+                        <a:spcBef>
+                          <a:spcPts val="0"/>
+                        </a:spcBef>
+                        <a:spcAft>
+                          <a:spcPts val="0"/>
+                        </a:spcAft>
+                        <a:buClrTx/>
+                        <a:buSzTx/>
+                        <a:buFontTx/>
+                        <a:buNone/>
+                        <a:tabLst/>
+                        <a:defRPr/>
+                      </a:pPr>
+                      <a:r>
+                        <a:rPr lang="de-DE" sz="1400" dirty="0" err="1">
+                          <a:latin typeface="72 Monospace" panose="020B0509030603020204" pitchFamily="49" charset="0"/>
+                          <a:cs typeface="72 Monospace" panose="020B0509030603020204" pitchFamily="49" charset="0"/>
+                        </a:rPr>
+                        <a:t>display:block</a:t>
+                      </a:r>
+                      <a:r>
+                        <a:rPr lang="de-DE" sz="1400" dirty="0">
+                          <a:latin typeface="72 Monospace" panose="020B0509030603020204" pitchFamily="49" charset="0"/>
+                          <a:cs typeface="72 Monospace" panose="020B0509030603020204" pitchFamily="49" charset="0"/>
+                        </a:rPr>
+                        <a:t>; height:1ex;</a:t>
+                      </a:r>
+                    </a:p>
+                  </a:txBody>
+                  <a:tcPr/>
+                </a:tc>
+                <a:extLst>
+                  <a:ext uri="{0D108BD9-81ED-4DB2-BD59-A6C34878D82A}">
+                    <a16:rowId xmlns:a16="http://schemas.microsoft.com/office/drawing/2014/main" val="1395546556"/>
+                  </a:ext>
+                </a:extLst>
+              </a:tr>
+              <a:tr h="381428">
+                <a:tc>
+                  <a:txBody>
+                    <a:bodyPr/>
+                    <a:lstStyle/>
+                    <a:p>
+                      <a:r>
+                        <a:rPr lang="de-DE" dirty="0">
+                          <a:latin typeface="72 Monospace" panose="020B0509030603020204" pitchFamily="49" charset="0"/>
+                          <a:cs typeface="72 Monospace" panose="020B0509030603020204" pitchFamily="49" charset="0"/>
+                        </a:rPr>
+                        <a:t>/VVS   </a:t>
+                      </a:r>
+                      <a:r>
+                        <a:rPr lang="de-DE" dirty="0">
+                          <a:latin typeface="+mn-lt"/>
+                          <a:cs typeface="72 Monospace" panose="020B0509030603020204" pitchFamily="49" charset="0"/>
+                        </a:rPr>
+                        <a:t>(</a:t>
+                      </a:r>
+                      <a:r>
+                        <a:rPr lang="de-DE" i="1" dirty="0" err="1">
+                          <a:latin typeface="+mn-lt"/>
+                          <a:cs typeface="72 Monospace" panose="020B0509030603020204" pitchFamily="49" charset="0"/>
+                        </a:rPr>
+                        <a:t>vertical</a:t>
+                      </a:r>
+                      <a:r>
+                        <a:rPr lang="de-DE" i="1" dirty="0">
+                          <a:latin typeface="+mn-lt"/>
+                          <a:cs typeface="72 Monospace" panose="020B0509030603020204" pitchFamily="49" charset="0"/>
+                        </a:rPr>
+                        <a:t> </a:t>
+                      </a:r>
+                      <a:r>
+                        <a:rPr lang="de-DE" i="1" dirty="0" err="1">
+                          <a:latin typeface="+mn-lt"/>
+                          <a:cs typeface="72 Monospace" panose="020B0509030603020204" pitchFamily="49" charset="0"/>
+                        </a:rPr>
+                        <a:t>space</a:t>
+                      </a:r>
+                      <a:r>
+                        <a:rPr lang="de-DE" i="1" dirty="0">
+                          <a:latin typeface="+mn-lt"/>
+                          <a:cs typeface="72 Monospace" panose="020B0509030603020204" pitchFamily="49" charset="0"/>
+                        </a:rPr>
+                        <a:t> 2</a:t>
+                      </a:r>
+                      <a:r>
+                        <a:rPr lang="de-DE" dirty="0">
+                          <a:latin typeface="+mn-lt"/>
+                          <a:cs typeface="72 Monospace" panose="020B0509030603020204" pitchFamily="49" charset="0"/>
+                        </a:rPr>
+                        <a:t>)</a:t>
+                      </a:r>
+                      <a:endParaRPr lang="de-DE" dirty="0">
+                        <a:latin typeface="72 Monospace" panose="020B0509030603020204" pitchFamily="49" charset="0"/>
+                        <a:cs typeface="72 Monospace" panose="020B0509030603020204" pitchFamily="49" charset="0"/>
+                      </a:endParaRPr>
+                    </a:p>
+                  </a:txBody>
+                  <a:tcPr/>
+                </a:tc>
+                <a:tc>
+                  <a:txBody>
+                    <a:bodyPr/>
+                    <a:lstStyle/>
+                    <a:p>
+                      <a:pPr marL="0" marR="0" lvl="0" indent="0" algn="l" defTabSz="914333" rtl="0" eaLnBrk="1" fontAlgn="auto" latinLnBrk="0" hangingPunct="1">
+                        <a:lnSpc>
+                          <a:spcPct val="100000"/>
+                        </a:lnSpc>
+                        <a:spcBef>
+                          <a:spcPts val="0"/>
+                        </a:spcBef>
+                        <a:spcAft>
+                          <a:spcPts val="0"/>
+                        </a:spcAft>
+                        <a:buClrTx/>
+                        <a:buSzTx/>
+                        <a:buFontTx/>
+                        <a:buNone/>
+                        <a:tabLst/>
+                        <a:defRPr/>
+                      </a:pPr>
+                      <a:r>
+                        <a:rPr lang="de-DE" i="0" dirty="0">
+                          <a:solidFill>
+                            <a:schemeClr val="tx1"/>
+                          </a:solidFill>
+                          <a:latin typeface="72 Monospace" panose="020B0509030603020204" pitchFamily="49" charset="0"/>
+                          <a:cs typeface="72 Monospace" panose="020B0509030603020204" pitchFamily="49" charset="0"/>
+                        </a:rPr>
+                        <a:t>\</a:t>
+                      </a:r>
+                      <a:r>
+                        <a:rPr lang="de-DE" i="0" dirty="0" err="1">
+                          <a:solidFill>
+                            <a:schemeClr val="tx1"/>
+                          </a:solidFill>
+                          <a:latin typeface="72 Monospace" panose="020B0509030603020204" pitchFamily="49" charset="0"/>
+                          <a:cs typeface="72 Monospace" panose="020B0509030603020204" pitchFamily="49" charset="0"/>
+                        </a:rPr>
+                        <a:t>vspace</a:t>
+                      </a:r>
+                      <a:r>
+                        <a:rPr lang="de-DE" i="0" dirty="0">
+                          <a:solidFill>
+                            <a:schemeClr val="tx1"/>
+                          </a:solidFill>
+                          <a:latin typeface="72 Monospace" panose="020B0509030603020204" pitchFamily="49" charset="0"/>
+                          <a:cs typeface="72 Monospace" panose="020B0509030603020204" pitchFamily="49" charset="0"/>
+                        </a:rPr>
+                        <a:t>{2ex}</a:t>
+                      </a:r>
+                    </a:p>
+                  </a:txBody>
+                  <a:tcPr/>
+                </a:tc>
+                <a:tc>
+                  <a:txBody>
+                    <a:bodyPr/>
+                    <a:lstStyle/>
+                    <a:p>
+                      <a:pPr marL="0" marR="0" lvl="0" indent="0" algn="l" defTabSz="914333" rtl="0" eaLnBrk="1" fontAlgn="auto" latinLnBrk="0" hangingPunct="1">
+                        <a:lnSpc>
+                          <a:spcPct val="100000"/>
+                        </a:lnSpc>
+                        <a:spcBef>
+                          <a:spcPts val="0"/>
+                        </a:spcBef>
+                        <a:spcAft>
+                          <a:spcPts val="0"/>
+                        </a:spcAft>
+                        <a:buClrTx/>
+                        <a:buSzTx/>
+                        <a:buFontTx/>
+                        <a:buNone/>
+                        <a:tabLst/>
+                        <a:defRPr/>
+                      </a:pPr>
+                      <a:r>
+                        <a:rPr lang="de-DE" sz="1400" dirty="0" err="1">
+                          <a:latin typeface="72 Monospace" panose="020B0509030603020204" pitchFamily="49" charset="0"/>
+                          <a:cs typeface="72 Monospace" panose="020B0509030603020204" pitchFamily="49" charset="0"/>
+                        </a:rPr>
+                        <a:t>display:block</a:t>
+                      </a:r>
+                      <a:r>
+                        <a:rPr lang="de-DE" sz="1400" dirty="0">
+                          <a:latin typeface="72 Monospace" panose="020B0509030603020204" pitchFamily="49" charset="0"/>
+                          <a:cs typeface="72 Monospace" panose="020B0509030603020204" pitchFamily="49" charset="0"/>
+                        </a:rPr>
+                        <a:t>; height:2ex;</a:t>
+                      </a:r>
+                    </a:p>
+                  </a:txBody>
+                  <a:tcPr/>
+                </a:tc>
+                <a:extLst>
+                  <a:ext uri="{0D108BD9-81ED-4DB2-BD59-A6C34878D82A}">
+                    <a16:rowId xmlns:a16="http://schemas.microsoft.com/office/drawing/2014/main" val="4032437628"/>
+                  </a:ext>
+                </a:extLst>
+              </a:tr>
+              <a:tr h="381428">
+                <a:tc>
+                  <a:txBody>
+                    <a:bodyPr/>
+                    <a:lstStyle/>
+                    <a:p>
+                      <a:r>
+                        <a:rPr lang="de-DE" dirty="0">
+                          <a:latin typeface="72 Monospace" panose="020B0509030603020204" pitchFamily="49" charset="0"/>
+                          <a:cs typeface="72 Monospace" panose="020B0509030603020204" pitchFamily="49" charset="0"/>
+                        </a:rPr>
+                        <a:t>/VVVS  </a:t>
+                      </a:r>
+                      <a:r>
+                        <a:rPr lang="de-DE" dirty="0">
+                          <a:latin typeface="+mn-lt"/>
+                          <a:cs typeface="72 Monospace" panose="020B0509030603020204" pitchFamily="49" charset="0"/>
+                        </a:rPr>
+                        <a:t>(</a:t>
+                      </a:r>
+                      <a:r>
+                        <a:rPr lang="de-DE" i="1" dirty="0" err="1">
+                          <a:latin typeface="+mn-lt"/>
+                          <a:cs typeface="72 Monospace" panose="020B0509030603020204" pitchFamily="49" charset="0"/>
+                        </a:rPr>
+                        <a:t>vertical</a:t>
+                      </a:r>
+                      <a:r>
+                        <a:rPr lang="de-DE" i="1" dirty="0">
+                          <a:latin typeface="+mn-lt"/>
+                          <a:cs typeface="72 Monospace" panose="020B0509030603020204" pitchFamily="49" charset="0"/>
+                        </a:rPr>
+                        <a:t> </a:t>
+                      </a:r>
+                      <a:r>
+                        <a:rPr lang="de-DE" i="1" dirty="0" err="1">
+                          <a:latin typeface="+mn-lt"/>
+                          <a:cs typeface="72 Monospace" panose="020B0509030603020204" pitchFamily="49" charset="0"/>
+                        </a:rPr>
+                        <a:t>space</a:t>
+                      </a:r>
+                      <a:r>
+                        <a:rPr lang="de-DE" i="1" dirty="0">
+                          <a:latin typeface="+mn-lt"/>
+                          <a:cs typeface="72 Monospace" panose="020B0509030603020204" pitchFamily="49" charset="0"/>
+                        </a:rPr>
+                        <a:t> 3</a:t>
+                      </a:r>
+                      <a:r>
+                        <a:rPr lang="de-DE" dirty="0">
+                          <a:latin typeface="+mn-lt"/>
+                          <a:cs typeface="72 Monospace" panose="020B0509030603020204" pitchFamily="49" charset="0"/>
+                        </a:rPr>
+                        <a:t>)</a:t>
+                      </a:r>
+                      <a:endParaRPr lang="de-DE" dirty="0">
+                        <a:latin typeface="72 Monospace" panose="020B0509030603020204" pitchFamily="49" charset="0"/>
+                        <a:cs typeface="72 Monospace" panose="020B0509030603020204" pitchFamily="49" charset="0"/>
+                      </a:endParaRPr>
+                    </a:p>
+                  </a:txBody>
+                  <a:tcPr/>
+                </a:tc>
+                <a:tc>
+                  <a:txBody>
+                    <a:bodyPr/>
+                    <a:lstStyle/>
+                    <a:p>
+                      <a:pPr marL="0" marR="0" lvl="0" indent="0" algn="l" defTabSz="914333" rtl="0" eaLnBrk="1" fontAlgn="auto" latinLnBrk="0" hangingPunct="1">
+                        <a:lnSpc>
+                          <a:spcPct val="100000"/>
+                        </a:lnSpc>
+                        <a:spcBef>
+                          <a:spcPts val="0"/>
+                        </a:spcBef>
+                        <a:spcAft>
+                          <a:spcPts val="0"/>
+                        </a:spcAft>
+                        <a:buClrTx/>
+                        <a:buSzTx/>
+                        <a:buFontTx/>
+                        <a:buNone/>
+                        <a:tabLst/>
+                        <a:defRPr/>
+                      </a:pPr>
+                      <a:r>
+                        <a:rPr lang="de-DE" sz="1800" i="0" kern="1200" dirty="0">
+                          <a:solidFill>
+                            <a:schemeClr val="tx1"/>
+                          </a:solidFill>
+                          <a:latin typeface="72 Monospace" panose="020B0509030603020204" pitchFamily="49" charset="0"/>
+                          <a:ea typeface="+mn-ea"/>
+                          <a:cs typeface="72 Monospace" panose="020B0509030603020204" pitchFamily="49" charset="0"/>
+                        </a:rPr>
+                        <a:t>\</a:t>
+                      </a:r>
+                      <a:r>
+                        <a:rPr lang="de-DE" sz="1800" i="0" kern="1200" dirty="0" err="1">
+                          <a:solidFill>
+                            <a:schemeClr val="tx1"/>
+                          </a:solidFill>
+                          <a:latin typeface="72 Monospace" panose="020B0509030603020204" pitchFamily="49" charset="0"/>
+                          <a:ea typeface="+mn-ea"/>
+                          <a:cs typeface="72 Monospace" panose="020B0509030603020204" pitchFamily="49" charset="0"/>
+                        </a:rPr>
+                        <a:t>vspace</a:t>
+                      </a:r>
+                      <a:r>
+                        <a:rPr lang="de-DE" sz="1800" i="0" kern="1200" dirty="0">
+                          <a:solidFill>
+                            <a:schemeClr val="tx1"/>
+                          </a:solidFill>
+                          <a:latin typeface="72 Monospace" panose="020B0509030603020204" pitchFamily="49" charset="0"/>
+                          <a:ea typeface="+mn-ea"/>
+                          <a:cs typeface="72 Monospace" panose="020B0509030603020204" pitchFamily="49" charset="0"/>
+                        </a:rPr>
+                        <a:t>{3ex}</a:t>
+                      </a:r>
+                    </a:p>
+                  </a:txBody>
+                  <a:tcPr/>
+                </a:tc>
+                <a:tc>
+                  <a:txBody>
+                    <a:bodyPr/>
+                    <a:lstStyle/>
+                    <a:p>
+                      <a:pPr marL="0" marR="0" lvl="0" indent="0" algn="l" defTabSz="914333" rtl="0" eaLnBrk="1" fontAlgn="auto" latinLnBrk="0" hangingPunct="1">
+                        <a:lnSpc>
+                          <a:spcPct val="100000"/>
+                        </a:lnSpc>
+                        <a:spcBef>
+                          <a:spcPts val="0"/>
+                        </a:spcBef>
+                        <a:spcAft>
+                          <a:spcPts val="0"/>
+                        </a:spcAft>
+                        <a:buClrTx/>
+                        <a:buSzTx/>
+                        <a:buFontTx/>
+                        <a:buNone/>
+                        <a:tabLst/>
+                        <a:defRPr/>
+                      </a:pPr>
+                      <a:r>
+                        <a:rPr lang="de-DE" sz="1400" dirty="0" err="1">
+                          <a:latin typeface="72 Monospace" panose="020B0509030603020204" pitchFamily="49" charset="0"/>
+                          <a:cs typeface="72 Monospace" panose="020B0509030603020204" pitchFamily="49" charset="0"/>
+                        </a:rPr>
+                        <a:t>display:block</a:t>
+                      </a:r>
+                      <a:r>
+                        <a:rPr lang="de-DE" sz="1400" dirty="0">
+                          <a:latin typeface="72 Monospace" panose="020B0509030603020204" pitchFamily="49" charset="0"/>
+                          <a:cs typeface="72 Monospace" panose="020B0509030603020204" pitchFamily="49" charset="0"/>
+                        </a:rPr>
+                        <a:t>; height:3ex;</a:t>
+                      </a:r>
+                    </a:p>
+                  </a:txBody>
+                  <a:tcPr/>
+                </a:tc>
+                <a:extLst>
+                  <a:ext uri="{0D108BD9-81ED-4DB2-BD59-A6C34878D82A}">
+                    <a16:rowId xmlns:a16="http://schemas.microsoft.com/office/drawing/2014/main" val="2961811061"/>
+                  </a:ext>
+                </a:extLst>
+              </a:tr>
+              <a:tr h="381428">
+                <a:tc>
+                  <a:txBody>
+                    <a:bodyPr/>
+                    <a:lstStyle/>
+                    <a:p>
+                      <a:r>
+                        <a:rPr lang="de-DE" dirty="0">
+                          <a:latin typeface="72 Monospace" panose="020B0509030603020204" pitchFamily="49" charset="0"/>
+                          <a:cs typeface="72 Monospace" panose="020B0509030603020204" pitchFamily="49" charset="0"/>
+                        </a:rPr>
+                        <a:t>/BS    </a:t>
+                      </a:r>
+                      <a:r>
+                        <a:rPr lang="de-DE" dirty="0">
+                          <a:latin typeface="+mn-lt"/>
+                          <a:cs typeface="72 Monospace" panose="020B0509030603020204" pitchFamily="49" charset="0"/>
+                        </a:rPr>
+                        <a:t>(</a:t>
+                      </a:r>
+                      <a:r>
+                        <a:rPr lang="de-DE" i="1" dirty="0" err="1">
+                          <a:latin typeface="+mn-lt"/>
+                          <a:cs typeface="72 Monospace" panose="020B0509030603020204" pitchFamily="49" charset="0"/>
+                        </a:rPr>
+                        <a:t>backslash</a:t>
+                      </a:r>
+                      <a:r>
+                        <a:rPr lang="de-DE" dirty="0">
+                          <a:latin typeface="+mn-lt"/>
+                          <a:cs typeface="72 Monospace" panose="020B0509030603020204" pitchFamily="49" charset="0"/>
+                        </a:rPr>
+                        <a:t>)</a:t>
+                      </a:r>
+                      <a:endParaRPr lang="de-DE" dirty="0">
+                        <a:latin typeface="72 Monospace" panose="020B0509030603020204" pitchFamily="49" charset="0"/>
+                        <a:cs typeface="72 Monospace" panose="020B0509030603020204" pitchFamily="49" charset="0"/>
+                      </a:endParaRPr>
+                    </a:p>
+                  </a:txBody>
+                  <a:tcPr/>
+                </a:tc>
+                <a:tc>
+                  <a:txBody>
+                    <a:bodyPr/>
+                    <a:lstStyle/>
+                    <a:p>
+                      <a:pPr marL="0" marR="0" lvl="0" indent="0" algn="l" defTabSz="914333" rtl="0" eaLnBrk="1" fontAlgn="auto" latinLnBrk="0" hangingPunct="1">
+                        <a:lnSpc>
+                          <a:spcPct val="100000"/>
+                        </a:lnSpc>
+                        <a:spcBef>
+                          <a:spcPts val="0"/>
+                        </a:spcBef>
+                        <a:spcAft>
+                          <a:spcPts val="0"/>
+                        </a:spcAft>
+                        <a:buClrTx/>
+                        <a:buSzTx/>
+                        <a:buFontTx/>
+                        <a:buNone/>
+                        <a:tabLst/>
+                        <a:defRPr/>
+                      </a:pPr>
+                      <a:r>
+                        <a:rPr lang="de-DE" sz="1800" i="0" kern="1200" dirty="0">
+                          <a:solidFill>
+                            <a:schemeClr val="dk1"/>
+                          </a:solidFill>
+                          <a:latin typeface="72 Monospace" panose="020B0509030603020204" pitchFamily="49" charset="0"/>
+                          <a:ea typeface="+mn-ea"/>
+                          <a:cs typeface="72 Monospace" panose="020B0509030603020204" pitchFamily="49" charset="0"/>
+                        </a:rPr>
+                        <a:t>\</a:t>
+                      </a:r>
+                      <a:r>
+                        <a:rPr lang="de-DE" sz="1800" i="0" kern="1200" dirty="0" err="1">
+                          <a:solidFill>
+                            <a:schemeClr val="dk1"/>
+                          </a:solidFill>
+                          <a:latin typeface="72 Monospace" panose="020B0509030603020204" pitchFamily="49" charset="0"/>
+                          <a:ea typeface="+mn-ea"/>
+                          <a:cs typeface="72 Monospace" panose="020B0509030603020204" pitchFamily="49" charset="0"/>
+                        </a:rPr>
+                        <a:t>textbackslash</a:t>
+                      </a:r>
+                      <a:r>
+                        <a:rPr lang="de-DE" sz="1800" i="0" kern="1200" dirty="0">
+                          <a:solidFill>
+                            <a:schemeClr val="dk1"/>
+                          </a:solidFill>
+                          <a:latin typeface="72 Monospace" panose="020B0509030603020204" pitchFamily="49" charset="0"/>
+                          <a:ea typeface="+mn-ea"/>
+                          <a:cs typeface="72 Monospace" panose="020B0509030603020204" pitchFamily="49" charset="0"/>
+                        </a:rPr>
+                        <a:t>{}</a:t>
+                      </a:r>
+                    </a:p>
+                  </a:txBody>
+                  <a:tcPr/>
+                </a:tc>
+                <a:tc>
+                  <a:txBody>
+                    <a:bodyPr/>
+                    <a:lstStyle/>
+                    <a:p>
+                      <a:pPr marL="0" marR="0" lvl="0" indent="0" algn="l" defTabSz="914333" rtl="0" eaLnBrk="1" fontAlgn="auto" latinLnBrk="0" hangingPunct="1">
+                        <a:lnSpc>
+                          <a:spcPct val="100000"/>
+                        </a:lnSpc>
+                        <a:spcBef>
+                          <a:spcPts val="0"/>
+                        </a:spcBef>
+                        <a:spcAft>
+                          <a:spcPts val="0"/>
+                        </a:spcAft>
+                        <a:buClrTx/>
+                        <a:buSzTx/>
+                        <a:buFontTx/>
+                        <a:buNone/>
+                        <a:tabLst/>
+                        <a:defRPr/>
+                      </a:pPr>
+                      <a:r>
+                        <a:rPr lang="de-DE" sz="1800" i="0" kern="1200" dirty="0">
+                          <a:solidFill>
+                            <a:schemeClr val="dk1"/>
+                          </a:solidFill>
+                          <a:latin typeface="72 Monospace" panose="020B0509030603020204" pitchFamily="49" charset="0"/>
+                          <a:ea typeface="+mn-ea"/>
+                          <a:cs typeface="72 Monospace" panose="020B0509030603020204" pitchFamily="49" charset="0"/>
+                        </a:rPr>
+                        <a:t>\\</a:t>
+                      </a:r>
+                      <a:endParaRPr lang="de-DE" sz="1800" i="0" kern="1200" dirty="0">
+                        <a:solidFill>
+                          <a:schemeClr val="dk1"/>
+                        </a:solidFill>
+                        <a:latin typeface="+mn-lt"/>
+                        <a:ea typeface="+mn-ea"/>
+                        <a:cs typeface="72 Monospace" panose="020B0509030603020204" pitchFamily="49" charset="0"/>
+                      </a:endParaRPr>
+                    </a:p>
+                  </a:txBody>
+                  <a:tcPr/>
+                </a:tc>
+                <a:extLst>
+                  <a:ext uri="{0D108BD9-81ED-4DB2-BD59-A6C34878D82A}">
+                    <a16:rowId xmlns:a16="http://schemas.microsoft.com/office/drawing/2014/main" val="2045335331"/>
+                  </a:ext>
+                </a:extLst>
+              </a:tr>
+              <a:tr h="381428">
+                <a:tc>
+                  <a:txBody>
+                    <a:bodyPr/>
+                    <a:lstStyle/>
+                    <a:p>
+                      <a:r>
+                        <a:rPr lang="de-DE" dirty="0">
+                          <a:latin typeface="72 Monospace" panose="020B0509030603020204" pitchFamily="49" charset="0"/>
+                          <a:cs typeface="72 Monospace" panose="020B0509030603020204" pitchFamily="49" charset="0"/>
+                        </a:rPr>
+                        <a:t>/IBS   </a:t>
+                      </a:r>
+                      <a:r>
+                        <a:rPr lang="de-DE" dirty="0">
+                          <a:latin typeface="+mn-lt"/>
+                          <a:cs typeface="72 Monospace" panose="020B0509030603020204" pitchFamily="49" charset="0"/>
+                        </a:rPr>
+                        <a:t>(</a:t>
+                      </a:r>
+                      <a:r>
+                        <a:rPr lang="de-DE" i="1" dirty="0">
+                          <a:latin typeface="+mn-lt"/>
+                          <a:cs typeface="72 Monospace" panose="020B0509030603020204" pitchFamily="49" charset="0"/>
+                        </a:rPr>
+                        <a:t>inline </a:t>
+                      </a:r>
+                      <a:r>
+                        <a:rPr lang="de-DE" i="1" dirty="0" err="1">
+                          <a:latin typeface="+mn-lt"/>
+                          <a:cs typeface="72 Monospace" panose="020B0509030603020204" pitchFamily="49" charset="0"/>
+                        </a:rPr>
+                        <a:t>backslash</a:t>
+                      </a:r>
+                      <a:r>
+                        <a:rPr lang="de-DE" dirty="0">
+                          <a:latin typeface="+mn-lt"/>
+                          <a:cs typeface="72 Monospace" panose="020B0509030603020204" pitchFamily="49" charset="0"/>
+                        </a:rPr>
+                        <a:t>)</a:t>
+                      </a:r>
+                      <a:endParaRPr lang="de-DE" dirty="0">
+                        <a:latin typeface="72 Monospace" panose="020B0509030603020204" pitchFamily="49" charset="0"/>
+                        <a:cs typeface="72 Monospace" panose="020B0509030603020204" pitchFamily="49" charset="0"/>
+                      </a:endParaRPr>
+                    </a:p>
+                  </a:txBody>
+                  <a:tcPr/>
+                </a:tc>
+                <a:tc>
+                  <a:txBody>
+                    <a:bodyPr/>
+                    <a:lstStyle/>
+                    <a:p>
+                      <a:pPr marL="0" marR="0" lvl="0" indent="0" algn="l" defTabSz="914333" rtl="0" eaLnBrk="1" fontAlgn="auto" latinLnBrk="0" hangingPunct="1">
+                        <a:lnSpc>
+                          <a:spcPct val="100000"/>
+                        </a:lnSpc>
+                        <a:spcBef>
+                          <a:spcPts val="0"/>
+                        </a:spcBef>
+                        <a:spcAft>
+                          <a:spcPts val="0"/>
+                        </a:spcAft>
+                        <a:buClrTx/>
+                        <a:buSzTx/>
+                        <a:buFontTx/>
+                        <a:buNone/>
+                        <a:tabLst/>
+                        <a:defRPr/>
+                      </a:pPr>
+                      <a:r>
+                        <a:rPr lang="de-DE" sz="1800" i="0" kern="1200" dirty="0">
+                          <a:solidFill>
+                            <a:schemeClr val="dk1"/>
+                          </a:solidFill>
+                          <a:latin typeface="72 Monospace" panose="020B0509030603020204" pitchFamily="49" charset="0"/>
+                          <a:ea typeface="+mn-ea"/>
+                          <a:cs typeface="72 Monospace" panose="020B0509030603020204" pitchFamily="49" charset="0"/>
+                        </a:rPr>
+                        <a:t>\\</a:t>
+                      </a:r>
+                    </a:p>
+                  </a:txBody>
+                  <a:tcPr/>
+                </a:tc>
+                <a:tc>
+                  <a:txBody>
+                    <a:bodyPr/>
+                    <a:lstStyle/>
+                    <a:p>
+                      <a:pPr marL="0" marR="0" lvl="0" indent="0" algn="l" defTabSz="914333" rtl="0" eaLnBrk="1" fontAlgn="auto" latinLnBrk="0" hangingPunct="1">
+                        <a:lnSpc>
+                          <a:spcPct val="100000"/>
+                        </a:lnSpc>
+                        <a:spcBef>
+                          <a:spcPts val="0"/>
+                        </a:spcBef>
+                        <a:spcAft>
+                          <a:spcPts val="0"/>
+                        </a:spcAft>
+                        <a:buClrTx/>
+                        <a:buSzTx/>
+                        <a:buFontTx/>
+                        <a:buNone/>
+                        <a:tabLst/>
+                        <a:defRPr/>
+                      </a:pPr>
+                      <a:r>
+                        <a:rPr lang="de-DE" sz="1800" i="0" kern="1200" dirty="0">
+                          <a:solidFill>
+                            <a:schemeClr val="dk1"/>
+                          </a:solidFill>
+                          <a:latin typeface="72 Monospace" panose="020B0509030603020204" pitchFamily="49" charset="0"/>
+                          <a:ea typeface="+mn-ea"/>
+                          <a:cs typeface="72 Monospace" panose="020B0509030603020204" pitchFamily="49" charset="0"/>
+                        </a:rPr>
+                        <a:t>\\</a:t>
+                      </a:r>
+                      <a:endParaRPr lang="de-DE" sz="1800" i="0" kern="1200" dirty="0">
+                        <a:solidFill>
+                          <a:schemeClr val="dk1"/>
+                        </a:solidFill>
+                        <a:latin typeface="+mn-lt"/>
+                        <a:ea typeface="+mn-ea"/>
+                        <a:cs typeface="72 Monospace" panose="020B0509030603020204" pitchFamily="49" charset="0"/>
+                      </a:endParaRPr>
+                    </a:p>
+                  </a:txBody>
+                  <a:tcPr/>
+                </a:tc>
+                <a:extLst>
+                  <a:ext uri="{0D108BD9-81ED-4DB2-BD59-A6C34878D82A}">
+                    <a16:rowId xmlns:a16="http://schemas.microsoft.com/office/drawing/2014/main" val="265040130"/>
+                  </a:ext>
+                </a:extLst>
+              </a:tr>
+              <a:tr h="381428">
+                <a:tc>
+                  <a:txBody>
+                    <a:bodyPr/>
+                    <a:lstStyle/>
+                    <a:p>
+                      <a:r>
+                        <a:rPr lang="de-DE" dirty="0">
+                          <a:latin typeface="72 Monospace" panose="020B0509030603020204" pitchFamily="49" charset="0"/>
+                          <a:cs typeface="72 Monospace" panose="020B0509030603020204" pitchFamily="49" charset="0"/>
+                        </a:rPr>
+                        <a:t>/HS    </a:t>
+                      </a:r>
+                      <a:r>
+                        <a:rPr lang="de-DE" dirty="0">
+                          <a:latin typeface="+mn-lt"/>
+                          <a:cs typeface="72 Monospace" panose="020B0509030603020204" pitchFamily="49" charset="0"/>
+                        </a:rPr>
+                        <a:t>(</a:t>
+                      </a:r>
+                      <a:r>
+                        <a:rPr lang="de-DE" i="1" dirty="0">
+                          <a:latin typeface="+mn-lt"/>
+                          <a:cs typeface="72 Monospace" panose="020B0509030603020204" pitchFamily="49" charset="0"/>
+                        </a:rPr>
+                        <a:t>horizontal </a:t>
+                      </a:r>
+                      <a:r>
+                        <a:rPr lang="de-DE" i="1" dirty="0" err="1">
+                          <a:latin typeface="+mn-lt"/>
+                          <a:cs typeface="72 Monospace" panose="020B0509030603020204" pitchFamily="49" charset="0"/>
+                        </a:rPr>
+                        <a:t>space</a:t>
+                      </a:r>
+                      <a:r>
+                        <a:rPr lang="de-DE" dirty="0">
+                          <a:latin typeface="+mn-lt"/>
+                          <a:cs typeface="72 Monospace" panose="020B0509030603020204" pitchFamily="49" charset="0"/>
+                        </a:rPr>
+                        <a:t>)</a:t>
+                      </a:r>
+                      <a:endParaRPr lang="de-DE" dirty="0">
+                        <a:latin typeface="72 Monospace" panose="020B0509030603020204" pitchFamily="49" charset="0"/>
+                        <a:cs typeface="72 Monospace" panose="020B0509030603020204" pitchFamily="49" charset="0"/>
+                      </a:endParaRPr>
+                    </a:p>
+                  </a:txBody>
+                  <a:tcPr/>
+                </a:tc>
+                <a:tc>
+                  <a:txBody>
+                    <a:bodyPr/>
+                    <a:lstStyle/>
+                    <a:p>
+                      <a:pPr marL="0" marR="0" lvl="0" indent="0" algn="l" defTabSz="914333" rtl="0" eaLnBrk="1" fontAlgn="auto" latinLnBrk="0" hangingPunct="1">
+                        <a:lnSpc>
+                          <a:spcPct val="100000"/>
+                        </a:lnSpc>
+                        <a:spcBef>
+                          <a:spcPts val="0"/>
+                        </a:spcBef>
+                        <a:spcAft>
+                          <a:spcPts val="0"/>
+                        </a:spcAft>
+                        <a:buClrTx/>
+                        <a:buSzTx/>
+                        <a:buFontTx/>
+                        <a:buNone/>
+                        <a:tabLst/>
+                        <a:defRPr/>
+                      </a:pPr>
+                      <a:r>
+                        <a:rPr lang="de-DE" sz="1800" i="0" kern="1200" dirty="0">
+                          <a:solidFill>
+                            <a:schemeClr val="dk1"/>
+                          </a:solidFill>
+                          <a:latin typeface="72 Monospace" panose="020B0509030603020204" pitchFamily="49" charset="0"/>
+                          <a:ea typeface="+mn-ea"/>
+                          <a:cs typeface="72 Monospace" panose="020B0509030603020204" pitchFamily="49" charset="0"/>
+                        </a:rPr>
+                        <a:t>{\</a:t>
+                      </a:r>
+                      <a:r>
+                        <a:rPr lang="de-DE" sz="1800" i="0" kern="1200" dirty="0" err="1">
+                          <a:solidFill>
+                            <a:schemeClr val="dk1"/>
+                          </a:solidFill>
+                          <a:latin typeface="72 Monospace" panose="020B0509030603020204" pitchFamily="49" charset="0"/>
+                          <a:ea typeface="+mn-ea"/>
+                          <a:cs typeface="72 Monospace" panose="020B0509030603020204" pitchFamily="49" charset="0"/>
+                        </a:rPr>
+                        <a:t>ttfamily</a:t>
+                      </a:r>
+                      <a:r>
+                        <a:rPr lang="de-DE" sz="1800" i="0" kern="1200" dirty="0">
+                          <a:solidFill>
+                            <a:schemeClr val="dk1"/>
+                          </a:solidFill>
+                          <a:latin typeface="72 Monospace" panose="020B0509030603020204" pitchFamily="49" charset="0"/>
+                          <a:ea typeface="+mn-ea"/>
+                          <a:cs typeface="72 Monospace" panose="020B0509030603020204" pitchFamily="49" charset="0"/>
+                        </a:rPr>
+                        <a:t>\</a:t>
+                      </a:r>
+                      <a:r>
+                        <a:rPr lang="de-DE" sz="1800" i="0" kern="1200" dirty="0" err="1">
+                          <a:solidFill>
+                            <a:schemeClr val="dk1"/>
+                          </a:solidFill>
+                          <a:latin typeface="72 Monospace" panose="020B0509030603020204" pitchFamily="49" charset="0"/>
+                          <a:ea typeface="+mn-ea"/>
+                          <a:cs typeface="72 Monospace" panose="020B0509030603020204" pitchFamily="49" charset="0"/>
+                        </a:rPr>
+                        <a:t>hspace</a:t>
+                      </a:r>
+                      <a:r>
+                        <a:rPr lang="de-DE" sz="1800" i="0" kern="1200" dirty="0">
+                          <a:solidFill>
+                            <a:schemeClr val="dk1"/>
+                          </a:solidFill>
+                          <a:latin typeface="72 Monospace" panose="020B0509030603020204" pitchFamily="49" charset="0"/>
+                          <a:ea typeface="+mn-ea"/>
+                          <a:cs typeface="72 Monospace" panose="020B0509030603020204" pitchFamily="49" charset="0"/>
+                        </a:rPr>
+                        <a:t>{0.6em}}</a:t>
+                      </a:r>
+                    </a:p>
+                  </a:txBody>
+                  <a:tcPr/>
+                </a:tc>
+                <a:tc>
+                  <a:txBody>
+                    <a:bodyPr/>
+                    <a:lstStyle/>
+                    <a:p>
+                      <a:pPr marL="0" marR="0" lvl="0" indent="0" algn="l" defTabSz="914333" rtl="0" eaLnBrk="1" fontAlgn="auto" latinLnBrk="0" hangingPunct="1">
+                        <a:lnSpc>
+                          <a:spcPct val="100000"/>
+                        </a:lnSpc>
+                        <a:spcBef>
+                          <a:spcPts val="0"/>
+                        </a:spcBef>
+                        <a:spcAft>
+                          <a:spcPts val="0"/>
+                        </a:spcAft>
+                        <a:buClrTx/>
+                        <a:buSzTx/>
+                        <a:buFontTx/>
+                        <a:buNone/>
+                        <a:tabLst/>
+                        <a:defRPr/>
+                      </a:pPr>
+                      <a:r>
+                        <a:rPr lang="de-DE" sz="1800" i="0" kern="1200" dirty="0">
+                          <a:solidFill>
+                            <a:schemeClr val="dk1"/>
+                          </a:solidFill>
+                          <a:latin typeface="72 Monospace" panose="020B0509030603020204" pitchFamily="49" charset="0"/>
+                          <a:ea typeface="+mn-ea"/>
+                          <a:cs typeface="72 Monospace" panose="020B0509030603020204" pitchFamily="49" charset="0"/>
+                        </a:rPr>
+                        <a:t>&amp;nbsp;</a:t>
+                      </a:r>
+                    </a:p>
+                  </a:txBody>
+                  <a:tcPr/>
+                </a:tc>
+                <a:extLst>
+                  <a:ext uri="{0D108BD9-81ED-4DB2-BD59-A6C34878D82A}">
+                    <a16:rowId xmlns:a16="http://schemas.microsoft.com/office/drawing/2014/main" val="3990026879"/>
+                  </a:ext>
+                </a:extLst>
+              </a:tr>
+              <a:tr h="381428">
+                <a:tc>
+                  <a:txBody>
+                    <a:bodyPr/>
+                    <a:lstStyle/>
+                    <a:p>
+                      <a:r>
+                        <a:rPr lang="de-DE" dirty="0">
+                          <a:latin typeface="72 Monospace" panose="020B0509030603020204" pitchFamily="49" charset="0"/>
+                          <a:cs typeface="72 Monospace" panose="020B0509030603020204" pitchFamily="49" charset="0"/>
+                        </a:rPr>
+                        <a:t>/IHS   </a:t>
+                      </a:r>
+                      <a:r>
+                        <a:rPr lang="de-DE" dirty="0">
+                          <a:latin typeface="+mn-lt"/>
+                          <a:cs typeface="72 Monospace" panose="020B0509030603020204" pitchFamily="49" charset="0"/>
+                        </a:rPr>
+                        <a:t>(</a:t>
+                      </a:r>
+                      <a:r>
+                        <a:rPr lang="de-DE" i="1" dirty="0">
+                          <a:latin typeface="+mn-lt"/>
+                          <a:cs typeface="72 Monospace" panose="020B0509030603020204" pitchFamily="49" charset="0"/>
+                        </a:rPr>
+                        <a:t>inline horizontal </a:t>
+                      </a:r>
+                      <a:r>
+                        <a:rPr lang="de-DE" i="1" dirty="0" err="1">
+                          <a:latin typeface="+mn-lt"/>
+                          <a:cs typeface="72 Monospace" panose="020B0509030603020204" pitchFamily="49" charset="0"/>
+                        </a:rPr>
+                        <a:t>space</a:t>
+                      </a:r>
+                      <a:r>
+                        <a:rPr lang="de-DE" dirty="0">
+                          <a:latin typeface="+mn-lt"/>
+                          <a:cs typeface="72 Monospace" panose="020B0509030603020204" pitchFamily="49" charset="0"/>
+                        </a:rPr>
+                        <a:t>)</a:t>
+                      </a:r>
+                      <a:endParaRPr lang="de-DE" dirty="0">
+                        <a:latin typeface="72 Monospace" panose="020B0509030603020204" pitchFamily="49" charset="0"/>
+                        <a:cs typeface="72 Monospace" panose="020B0509030603020204" pitchFamily="49" charset="0"/>
+                      </a:endParaRPr>
+                    </a:p>
+                  </a:txBody>
+                  <a:tcPr/>
+                </a:tc>
+                <a:tc>
+                  <a:txBody>
+                    <a:bodyPr/>
+                    <a:lstStyle/>
+                    <a:p>
+                      <a:pPr marL="0" marR="0" lvl="0" indent="0" algn="l" defTabSz="914333" rtl="0" eaLnBrk="1" fontAlgn="auto" latinLnBrk="0" hangingPunct="1">
+                        <a:lnSpc>
+                          <a:spcPct val="100000"/>
+                        </a:lnSpc>
+                        <a:spcBef>
+                          <a:spcPts val="0"/>
+                        </a:spcBef>
+                        <a:spcAft>
+                          <a:spcPts val="0"/>
+                        </a:spcAft>
+                        <a:buClrTx/>
+                        <a:buSzTx/>
+                        <a:buFontTx/>
+                        <a:buNone/>
+                        <a:tabLst/>
+                        <a:defRPr/>
+                      </a:pPr>
+                      <a:r>
+                        <a:rPr lang="de-DE" sz="1800" i="0" kern="1200" dirty="0">
+                          <a:solidFill>
+                            <a:schemeClr val="dk1"/>
+                          </a:solidFill>
+                          <a:latin typeface="72 Monospace" panose="020B0509030603020204" pitchFamily="49" charset="0"/>
+                          <a:ea typeface="+mn-ea"/>
+                          <a:cs typeface="72 Monospace" panose="020B0509030603020204" pitchFamily="49" charset="0"/>
+                        </a:rPr>
+                        <a:t>{\</a:t>
+                      </a:r>
+                      <a:r>
+                        <a:rPr lang="de-DE" sz="1800" i="0" kern="1200" dirty="0" err="1">
+                          <a:solidFill>
+                            <a:schemeClr val="dk1"/>
+                          </a:solidFill>
+                          <a:latin typeface="72 Monospace" panose="020B0509030603020204" pitchFamily="49" charset="0"/>
+                          <a:ea typeface="+mn-ea"/>
+                          <a:cs typeface="72 Monospace" panose="020B0509030603020204" pitchFamily="49" charset="0"/>
+                        </a:rPr>
+                        <a:t>ttfamily</a:t>
+                      </a:r>
+                      <a:r>
+                        <a:rPr lang="de-DE" sz="1800" i="0" kern="1200" dirty="0">
+                          <a:solidFill>
+                            <a:schemeClr val="dk1"/>
+                          </a:solidFill>
+                          <a:latin typeface="72 Monospace" panose="020B0509030603020204" pitchFamily="49" charset="0"/>
+                          <a:ea typeface="+mn-ea"/>
+                          <a:cs typeface="72 Monospace" panose="020B0509030603020204" pitchFamily="49" charset="0"/>
+                        </a:rPr>
+                        <a:t>\</a:t>
+                      </a:r>
+                      <a:r>
+                        <a:rPr lang="de-DE" sz="1800" i="0" kern="1200" dirty="0" err="1">
+                          <a:solidFill>
+                            <a:schemeClr val="dk1"/>
+                          </a:solidFill>
+                          <a:latin typeface="72 Monospace" panose="020B0509030603020204" pitchFamily="49" charset="0"/>
+                          <a:ea typeface="+mn-ea"/>
+                          <a:cs typeface="72 Monospace" panose="020B0509030603020204" pitchFamily="49" charset="0"/>
+                        </a:rPr>
+                        <a:t>hspace</a:t>
+                      </a:r>
+                      <a:r>
+                        <a:rPr lang="de-DE" sz="1800" i="0" kern="1200" dirty="0">
+                          <a:solidFill>
+                            <a:schemeClr val="dk1"/>
+                          </a:solidFill>
+                          <a:latin typeface="72 Monospace" panose="020B0509030603020204" pitchFamily="49" charset="0"/>
+                          <a:ea typeface="+mn-ea"/>
+                          <a:cs typeface="72 Monospace" panose="020B0509030603020204" pitchFamily="49" charset="0"/>
+                        </a:rPr>
+                        <a:t>{0.6em}}</a:t>
+                      </a:r>
+                    </a:p>
+                  </a:txBody>
+                  <a:tcPr/>
+                </a:tc>
+                <a:tc>
+                  <a:txBody>
+                    <a:bodyPr/>
+                    <a:lstStyle/>
+                    <a:p>
+                      <a:pPr marL="0" marR="0" lvl="0" indent="0" algn="l" defTabSz="914333" rtl="0" eaLnBrk="1" fontAlgn="auto" latinLnBrk="0" hangingPunct="1">
+                        <a:lnSpc>
+                          <a:spcPct val="100000"/>
+                        </a:lnSpc>
+                        <a:spcBef>
+                          <a:spcPts val="0"/>
+                        </a:spcBef>
+                        <a:spcAft>
+                          <a:spcPts val="0"/>
+                        </a:spcAft>
+                        <a:buClrTx/>
+                        <a:buSzTx/>
+                        <a:buFontTx/>
+                        <a:buNone/>
+                        <a:tabLst/>
+                        <a:defRPr/>
+                      </a:pPr>
+                      <a:r>
+                        <a:rPr lang="de-DE" sz="1800" i="0" kern="1200" dirty="0">
+                          <a:solidFill>
+                            <a:schemeClr val="dk1"/>
+                          </a:solidFill>
+                          <a:latin typeface="72 Monospace" panose="020B0509030603020204" pitchFamily="49" charset="0"/>
+                          <a:ea typeface="+mn-ea"/>
+                          <a:cs typeface="72 Monospace" panose="020B0509030603020204" pitchFamily="49" charset="0"/>
+                        </a:rPr>
+                        <a:t>&amp;nbsp;</a:t>
+                      </a:r>
+                    </a:p>
+                  </a:txBody>
+                  <a:tcPr/>
+                </a:tc>
+                <a:extLst>
+                  <a:ext uri="{0D108BD9-81ED-4DB2-BD59-A6C34878D82A}">
+                    <a16:rowId xmlns:a16="http://schemas.microsoft.com/office/drawing/2014/main" val="1569298133"/>
+                  </a:ext>
+                </a:extLst>
+              </a:tr>
+              <a:tr h="381428">
+                <a:tc>
+                  <a:txBody>
+                    <a:bodyPr/>
+                    <a:lstStyle/>
+                    <a:p>
+                      <a:pPr marL="0" marR="0" lvl="0" indent="0" algn="l" defTabSz="914333" rtl="0" eaLnBrk="1" fontAlgn="auto" latinLnBrk="0" hangingPunct="1">
+                        <a:lnSpc>
+                          <a:spcPct val="100000"/>
+                        </a:lnSpc>
+                        <a:spcBef>
+                          <a:spcPts val="0"/>
+                        </a:spcBef>
+                        <a:spcAft>
+                          <a:spcPts val="0"/>
+                        </a:spcAft>
+                        <a:buClrTx/>
+                        <a:buSzTx/>
+                        <a:buFontTx/>
+                        <a:buNone/>
+                        <a:tabLst/>
+                        <a:defRPr/>
+                      </a:pPr>
+                      <a:r>
+                        <a:rPr lang="de-DE" dirty="0">
+                          <a:latin typeface="72 Monospace" panose="020B0509030603020204" pitchFamily="49" charset="0"/>
+                          <a:cs typeface="72 Monospace" panose="020B0509030603020204" pitchFamily="49" charset="0"/>
+                        </a:rPr>
+                        <a:t>/US    </a:t>
+                      </a:r>
+                      <a:r>
+                        <a:rPr lang="de-DE" dirty="0">
+                          <a:latin typeface="+mn-lt"/>
+                          <a:cs typeface="72 Monospace" panose="020B0509030603020204" pitchFamily="49" charset="0"/>
+                        </a:rPr>
+                        <a:t>(</a:t>
+                      </a:r>
+                      <a:r>
+                        <a:rPr lang="de-DE" i="1" dirty="0" err="1">
+                          <a:latin typeface="+mn-lt"/>
+                          <a:cs typeface="72 Monospace" panose="020B0509030603020204" pitchFamily="49" charset="0"/>
+                        </a:rPr>
+                        <a:t>underscore</a:t>
+                      </a:r>
+                      <a:r>
+                        <a:rPr lang="de-DE" dirty="0">
+                          <a:latin typeface="+mn-lt"/>
+                          <a:cs typeface="72 Monospace" panose="020B0509030603020204" pitchFamily="49" charset="0"/>
+                        </a:rPr>
+                        <a:t>)</a:t>
+                      </a:r>
+                      <a:endParaRPr lang="de-DE" dirty="0">
+                        <a:latin typeface="72 Monospace" panose="020B0509030603020204" pitchFamily="49" charset="0"/>
+                        <a:cs typeface="72 Monospace" panose="020B0509030603020204" pitchFamily="49" charset="0"/>
+                      </a:endParaRPr>
+                    </a:p>
+                  </a:txBody>
+                  <a:tcPr/>
+                </a:tc>
+                <a:tc>
+                  <a:txBody>
+                    <a:bodyPr/>
+                    <a:lstStyle/>
+                    <a:p>
+                      <a:pPr marL="0" marR="0" lvl="0" indent="0" algn="l" defTabSz="914333" rtl="0" eaLnBrk="1" fontAlgn="auto" latinLnBrk="0" hangingPunct="1">
+                        <a:lnSpc>
+                          <a:spcPct val="100000"/>
+                        </a:lnSpc>
+                        <a:spcBef>
+                          <a:spcPts val="0"/>
+                        </a:spcBef>
+                        <a:spcAft>
+                          <a:spcPts val="0"/>
+                        </a:spcAft>
+                        <a:buClrTx/>
+                        <a:buSzTx/>
+                        <a:buFontTx/>
+                        <a:buNone/>
+                        <a:tabLst/>
+                        <a:defRPr/>
+                      </a:pPr>
+                      <a:r>
+                        <a:rPr lang="de-DE" sz="1800" i="0" kern="1200" dirty="0">
+                          <a:solidFill>
+                            <a:schemeClr val="dk1"/>
+                          </a:solidFill>
+                          <a:latin typeface="72 Monospace" panose="020B0509030603020204" pitchFamily="49" charset="0"/>
+                          <a:ea typeface="+mn-ea"/>
+                          <a:cs typeface="72 Monospace" panose="020B0509030603020204" pitchFamily="49" charset="0"/>
+                        </a:rPr>
+                        <a:t>\_</a:t>
+                      </a:r>
+                    </a:p>
+                  </a:txBody>
+                  <a:tcPr/>
+                </a:tc>
+                <a:tc>
+                  <a:txBody>
+                    <a:bodyPr/>
+                    <a:lstStyle/>
+                    <a:p>
+                      <a:pPr marL="0" marR="0" lvl="0" indent="0" algn="l" defTabSz="914333" rtl="0" eaLnBrk="1" fontAlgn="auto" latinLnBrk="0" hangingPunct="1">
+                        <a:lnSpc>
+                          <a:spcPct val="100000"/>
+                        </a:lnSpc>
+                        <a:spcBef>
+                          <a:spcPts val="0"/>
+                        </a:spcBef>
+                        <a:spcAft>
+                          <a:spcPts val="0"/>
+                        </a:spcAft>
+                        <a:buClrTx/>
+                        <a:buSzTx/>
+                        <a:buFontTx/>
+                        <a:buNone/>
+                        <a:tabLst/>
+                        <a:defRPr/>
+                      </a:pPr>
+                      <a:r>
+                        <a:rPr lang="de-DE" sz="1800" i="0" kern="1200" dirty="0">
+                          <a:solidFill>
+                            <a:schemeClr val="dk1"/>
+                          </a:solidFill>
+                          <a:latin typeface="72 Monospace" panose="020B0509030603020204" pitchFamily="49" charset="0"/>
+                          <a:ea typeface="+mn-ea"/>
+                          <a:cs typeface="72 Monospace" panose="020B0509030603020204" pitchFamily="49" charset="0"/>
+                        </a:rPr>
+                        <a:t>_</a:t>
+                      </a:r>
+                    </a:p>
+                  </a:txBody>
+                  <a:tcPr/>
+                </a:tc>
+                <a:extLst>
+                  <a:ext uri="{0D108BD9-81ED-4DB2-BD59-A6C34878D82A}">
+                    <a16:rowId xmlns:a16="http://schemas.microsoft.com/office/drawing/2014/main" val="3539948172"/>
+                  </a:ext>
+                </a:extLst>
+              </a:tr>
+            </a:tbl>
+          </a:graphicData>
+        </a:graphic>
+      </p:graphicFrame>
+    </p:spTree>
+    <p:extLst>
+      <p:ext uri="{BB962C8B-B14F-4D97-AF65-F5344CB8AC3E}">
+        <p14:creationId xmlns:p14="http://schemas.microsoft.com/office/powerpoint/2010/main" val="2876854737"/>
+      </p:ext>
+    </p:extLst>
+  </p:cSld>
+  <p:clrMapOvr>
+    <a:masterClrMapping/>
+  </p:clrMapOvr>
+</p:sld>
+</file>
+
+<file path=ppt/slides/slide8.xml><?xml version="1.0" encoding="utf-8"?>
+<p:sld xmlns:a="http://schemas.openxmlformats.org/drawingml/2006/main" xmlns:r="http://schemas.openxmlformats.org/officeDocument/2006/relationships" xmlns:p="http://schemas.openxmlformats.org/presentationml/2006/main">
+  <p:cSld>
+    <p:spTree>
+      <p:nvGrpSpPr>
+        <p:cNvPr id="1" name="">
+          <a:extLst>
+            <a:ext uri="{FF2B5EF4-FFF2-40B4-BE49-F238E27FC236}">
+              <a16:creationId xmlns:a16="http://schemas.microsoft.com/office/drawing/2014/main" id="{EF3EA5F8-D040-5CB0-80C3-ED4594DD12D3}"/>
+            </a:ext>
+          </a:extLst>
+        </p:cNvPr>
+        <p:cNvGrpSpPr/>
+        <p:nvPr/>
+      </p:nvGrpSpPr>
+      <p:grpSpPr>
+        <a:xfrm>
+          <a:off x="0" y="0"/>
+          <a:ext cx="0" cy="0"/>
+          <a:chOff x="0" y="0"/>
+          <a:chExt cx="0" cy="0"/>
+        </a:xfrm>
+      </p:grpSpPr>
+      <p:sp>
+        <p:nvSpPr>
+          <p:cNvPr id="3" name="Textplatzhalter 2">
+            <a:extLst>
+              <a:ext uri="{FF2B5EF4-FFF2-40B4-BE49-F238E27FC236}">
+                <a16:creationId xmlns:a16="http://schemas.microsoft.com/office/drawing/2014/main" id="{6398C15C-97A1-8F10-D153-D35BC9354FE3}"/>
+              </a:ext>
+            </a:extLst>
+          </p:cNvPr>
+          <p:cNvSpPr>
+            <a:spLocks noGrp="1"/>
+          </p:cNvSpPr>
+          <p:nvPr>
+            <p:ph type="body" sz="quarter" idx="15"/>
+          </p:nvPr>
+        </p:nvSpPr>
+        <p:spPr/>
+        <p:txBody>
+          <a:bodyPr/>
+          <a:lstStyle/>
+          <a:p>
+            <a:r>
+              <a:rPr lang="de-DE" dirty="0"/>
+              <a:t>Syntax </a:t>
+            </a:r>
+            <a:r>
+              <a:rPr lang="de-DE" dirty="0" err="1"/>
+              <a:t>Extensions</a:t>
+            </a:r>
+            <a:endParaRPr lang="de-DE" dirty="0"/>
+          </a:p>
+        </p:txBody>
+      </p:sp>
+      <p:sp>
+        <p:nvSpPr>
+          <p:cNvPr id="4" name="Foliennummernplatzhalter 3">
+            <a:extLst>
+              <a:ext uri="{FF2B5EF4-FFF2-40B4-BE49-F238E27FC236}">
+                <a16:creationId xmlns:a16="http://schemas.microsoft.com/office/drawing/2014/main" id="{0CE5387B-2285-58C4-1B33-9DAE6E80BE05}"/>
+              </a:ext>
+            </a:extLst>
+          </p:cNvPr>
+          <p:cNvSpPr>
+            <a:spLocks noGrp="1"/>
+          </p:cNvSpPr>
+          <p:nvPr>
+            <p:ph type="sldNum" sz="quarter" idx="12"/>
+          </p:nvPr>
+        </p:nvSpPr>
+        <p:spPr/>
+        <p:txBody>
+          <a:bodyPr/>
+          <a:lstStyle/>
+          <a:p>
+            <a:fld id="{4898AEC0-503E-4FA4-859C-D0F72D6E3F79}" type="slidenum">
+              <a:rPr lang="en-US" noProof="1" smtClean="0"/>
+              <a:pPr/>
+              <a:t>8</a:t>
+            </a:fld>
+            <a:endParaRPr lang="en-US" noProof="1"/>
+          </a:p>
+        </p:txBody>
+      </p:sp>
+      <p:sp>
+        <p:nvSpPr>
+          <p:cNvPr id="2" name="Textfeld 1">
+            <a:extLst>
+              <a:ext uri="{FF2B5EF4-FFF2-40B4-BE49-F238E27FC236}">
+                <a16:creationId xmlns:a16="http://schemas.microsoft.com/office/drawing/2014/main" id="{9A547D8A-7D1B-3741-9A6E-A9BC10FAEA33}"/>
+              </a:ext>
+            </a:extLst>
+          </p:cNvPr>
+          <p:cNvSpPr txBox="1"/>
+          <p:nvPr/>
+        </p:nvSpPr>
+        <p:spPr>
+          <a:xfrm>
+            <a:off x="266700" y="702701"/>
+            <a:ext cx="9552549" cy="388801"/>
+          </a:xfrm>
+          <a:prstGeom prst="rect">
+            <a:avLst/>
+          </a:prstGeom>
+          <a:noFill/>
+        </p:spPr>
+        <p:txBody>
+          <a:bodyPr wrap="square" lIns="0" tIns="0" rIns="0" bIns="0" rtlCol="0">
+            <a:noAutofit/>
+          </a:bodyPr>
+          <a:lstStyle/>
+          <a:p>
+            <a:pPr marR="0" defTabSz="914400" eaLnBrk="1" fontAlgn="auto" latinLnBrk="0" hangingPunct="1">
               <a:lnSpc>
                 <a:spcPts val="2300"/>
               </a:lnSpc>
@@ -20324,10 +23288,10 @@
                 <a:uLnTx/>
                 <a:uFillTx/>
               </a:rPr>
-              <a:t>With </a:t>
-            </a:r>
-            <a:r>
-              <a:rPr kumimoji="0" lang="de-DE" sz="1200" b="1" i="0" u="none" strike="noStrike" kern="0" cap="none" spc="0" normalizeH="0" baseline="0" noProof="0" dirty="0" err="1">
+              <a:t>Additional </a:t>
+            </a:r>
+            <a:r>
+              <a:rPr kumimoji="0" lang="de-DE" sz="1200" i="0" u="none" strike="noStrike" kern="0" cap="none" spc="0" normalizeH="0" baseline="0" noProof="0" dirty="0" err="1">
                 <a:ln>
                   <a:noFill/>
                 </a:ln>
@@ -20338,7 +23302,7 @@
                 <a:uLnTx/>
                 <a:uFillTx/>
               </a:rPr>
-              <a:t>GenPackageDoc</a:t>
+              <a:t>reST</a:t>
             </a:r>
             <a:r>
               <a:rPr kumimoji="0" lang="de-DE" sz="1200" i="0" u="none" strike="noStrike" kern="0" cap="none" spc="0" normalizeH="0" baseline="0" noProof="0" dirty="0">
@@ -20366,7 +23330,7 @@
                 <a:uLnTx/>
                 <a:uFillTx/>
               </a:rPr>
-              <a:t>version</a:t>
+              <a:t>syntax</a:t>
             </a:r>
             <a:r>
               <a:rPr kumimoji="0" lang="de-DE" sz="1200" i="0" u="none" strike="noStrike" kern="0" cap="none" spc="0" normalizeH="0" baseline="0" noProof="0" dirty="0">
@@ -20383,7 +23347,7 @@
               <a:t> </a:t>
             </a:r>
             <a:r>
-              <a:rPr kumimoji="0" lang="de-DE" sz="1200" b="1" i="0" u="none" strike="noStrike" kern="0" cap="none" spc="0" normalizeH="0" baseline="0" noProof="0" dirty="0">
+              <a:rPr kumimoji="0" lang="de-DE" sz="1200" i="0" u="none" strike="noStrike" kern="0" cap="none" spc="0" normalizeH="0" baseline="0" noProof="0" dirty="0" err="1">
                 <a:ln>
                   <a:noFill/>
                 </a:ln>
@@ -20394,7 +23358,7 @@
                 <a:uLnTx/>
                 <a:uFillTx/>
               </a:rPr>
-              <a:t>0.43.0</a:t>
+              <a:t>elements</a:t>
             </a:r>
             <a:r>
               <a:rPr kumimoji="0" lang="de-DE" sz="1200" i="0" u="none" strike="noStrike" kern="0" cap="none" spc="0" normalizeH="0" baseline="0" noProof="0" dirty="0">
@@ -20408,7 +23372,7 @@
                 <a:uLnTx/>
                 <a:uFillTx/>
               </a:rPr>
-              <a:t>, </a:t>
+              <a:t> </a:t>
             </a:r>
             <a:r>
               <a:rPr kumimoji="0" lang="de-DE" sz="1200" i="0" u="none" strike="noStrike" kern="0" cap="none" spc="0" normalizeH="0" baseline="0" noProof="0" dirty="0" err="1">
@@ -20422,7 +23386,7 @@
                 <a:uLnTx/>
                 <a:uFillTx/>
               </a:rPr>
-              <a:t>the</a:t>
+              <a:t>that</a:t>
             </a:r>
             <a:r>
               <a:rPr kumimoji="0" lang="de-DE" sz="1200" i="0" u="none" strike="noStrike" kern="0" cap="none" spc="0" normalizeH="0" baseline="0" noProof="0" dirty="0">
@@ -20450,7 +23414,7 @@
                 <a:uLnTx/>
                 <a:uFillTx/>
               </a:rPr>
-              <a:t>language</a:t>
+              <a:t>are</a:t>
             </a:r>
             <a:r>
               <a:rPr kumimoji="0" lang="de-DE" sz="1200" i="0" u="none" strike="noStrike" kern="0" cap="none" spc="0" normalizeH="0" baseline="0" noProof="0" dirty="0">
@@ -20478,7 +23442,7 @@
                 <a:uLnTx/>
                 <a:uFillTx/>
               </a:rPr>
-              <a:t>elements</a:t>
+              <a:t>mapped</a:t>
             </a:r>
             <a:r>
               <a:rPr kumimoji="0" lang="de-DE" sz="1200" i="0" u="none" strike="noStrike" kern="0" cap="none" spc="0" normalizeH="0" baseline="0" noProof="0" dirty="0">
@@ -20506,7 +23470,7 @@
                 <a:uLnTx/>
                 <a:uFillTx/>
               </a:rPr>
-              <a:t>have</a:t>
+              <a:t>to</a:t>
             </a:r>
             <a:r>
               <a:rPr kumimoji="0" lang="de-DE" sz="1200" i="0" u="none" strike="noStrike" kern="0" cap="none" spc="0" normalizeH="0" baseline="0" noProof="0" dirty="0">
@@ -20534,7 +23498,7 @@
                 <a:uLnTx/>
                 <a:uFillTx/>
               </a:rPr>
-              <a:t>been</a:t>
+              <a:t>LaTeX</a:t>
             </a:r>
             <a:r>
               <a:rPr kumimoji="0" lang="de-DE" sz="1200" i="0" u="none" strike="noStrike" kern="0" cap="none" spc="0" normalizeH="0" baseline="0" noProof="0" dirty="0">
@@ -20562,7 +23526,7 @@
                 <a:uLnTx/>
                 <a:uFillTx/>
               </a:rPr>
-              <a:t>reworked</a:t>
+              <a:t>output</a:t>
             </a:r>
             <a:r>
               <a:rPr kumimoji="0" lang="de-DE" sz="1200" i="0" u="none" strike="noStrike" kern="0" cap="none" spc="0" normalizeH="0" baseline="0" noProof="0" dirty="0">
@@ -20576,7 +23540,7 @@
                 <a:uLnTx/>
                 <a:uFillTx/>
               </a:rPr>
-              <a:t>. </a:t>
+              <a:t> and HTML </a:t>
             </a:r>
             <a:r>
               <a:rPr kumimoji="0" lang="de-DE" sz="1200" i="0" u="none" strike="noStrike" kern="0" cap="none" spc="0" normalizeH="0" baseline="0" noProof="0" dirty="0" err="1">
@@ -20590,7 +23554,7 @@
                 <a:uLnTx/>
                 <a:uFillTx/>
               </a:rPr>
-              <a:t>Some</a:t>
+              <a:t>output</a:t>
             </a:r>
             <a:r>
               <a:rPr kumimoji="0" lang="de-DE" sz="1200" i="0" u="none" strike="noStrike" kern="0" cap="none" spc="0" normalizeH="0" baseline="0" noProof="0" dirty="0">
@@ -20604,7 +23568,7 @@
                 <a:uLnTx/>
                 <a:uFillTx/>
               </a:rPr>
-              <a:t> </a:t>
+              <a:t> in a different </a:t>
             </a:r>
             <a:r>
               <a:rPr kumimoji="0" lang="de-DE" sz="1200" i="0" u="none" strike="noStrike" kern="0" cap="none" spc="0" normalizeH="0" baseline="0" noProof="0" dirty="0" err="1">
@@ -20618,7 +23582,7 @@
                 <a:uLnTx/>
                 <a:uFillTx/>
               </a:rPr>
-              <a:t>of</a:t>
+              <a:t>way</a:t>
             </a:r>
             <a:r>
               <a:rPr kumimoji="0" lang="de-DE" sz="1200" i="0" u="none" strike="noStrike" kern="0" cap="none" spc="0" normalizeH="0" baseline="0" noProof="0" dirty="0">
@@ -20632,399 +23596,7 @@
                 <a:uLnTx/>
                 <a:uFillTx/>
               </a:rPr>
-              <a:t> </a:t>
-            </a:r>
-            <a:r>
-              <a:rPr kumimoji="0" lang="de-DE" sz="1200" i="0" u="none" strike="noStrike" kern="0" cap="none" spc="0" normalizeH="0" baseline="0" noProof="0" dirty="0" err="1">
-                <a:ln>
-                  <a:noFill/>
-                </a:ln>
-                <a:solidFill>
-                  <a:srgbClr val="000000"/>
-                </a:solidFill>
-                <a:effectLst/>
-                <a:uLnTx/>
-                <a:uFillTx/>
-              </a:rPr>
-              <a:t>them</a:t>
-            </a:r>
-            <a:r>
-              <a:rPr kumimoji="0" lang="de-DE" sz="1200" i="0" u="none" strike="noStrike" kern="0" cap="none" spc="0" normalizeH="0" baseline="0" noProof="0" dirty="0">
-                <a:ln>
-                  <a:noFill/>
-                </a:ln>
-                <a:solidFill>
-                  <a:srgbClr val="000000"/>
-                </a:solidFill>
-                <a:effectLst/>
-                <a:uLnTx/>
-                <a:uFillTx/>
-              </a:rPr>
-              <a:t> </a:t>
-            </a:r>
-            <a:r>
-              <a:rPr kumimoji="0" lang="de-DE" sz="1200" i="0" u="none" strike="noStrike" kern="0" cap="none" spc="0" normalizeH="0" baseline="0" noProof="0" dirty="0" err="1">
-                <a:ln>
-                  <a:noFill/>
-                </a:ln>
-                <a:solidFill>
-                  <a:srgbClr val="000000"/>
-                </a:solidFill>
-                <a:effectLst/>
-                <a:uLnTx/>
-                <a:uFillTx/>
-              </a:rPr>
-              <a:t>are</a:t>
-            </a:r>
-            <a:r>
-              <a:rPr kumimoji="0" lang="de-DE" sz="1200" i="0" u="none" strike="noStrike" kern="0" cap="none" spc="0" normalizeH="0" baseline="0" noProof="0" dirty="0">
-                <a:ln>
-                  <a:noFill/>
-                </a:ln>
-                <a:solidFill>
-                  <a:srgbClr val="000000"/>
-                </a:solidFill>
-                <a:effectLst/>
-                <a:uLnTx/>
-                <a:uFillTx/>
-              </a:rPr>
-              <a:t> </a:t>
-            </a:r>
-            <a:r>
-              <a:rPr kumimoji="0" lang="de-DE" sz="1200" i="0" u="none" strike="noStrike" kern="0" cap="none" spc="0" normalizeH="0" baseline="0" noProof="0" dirty="0" err="1">
-                <a:ln>
-                  <a:noFill/>
-                </a:ln>
-                <a:solidFill>
-                  <a:srgbClr val="000000"/>
-                </a:solidFill>
-                <a:effectLst/>
-                <a:uLnTx/>
-                <a:uFillTx/>
-              </a:rPr>
-              <a:t>deprecated</a:t>
-            </a:r>
-            <a:r>
-              <a:rPr kumimoji="0" lang="de-DE" sz="1200" i="0" u="none" strike="noStrike" kern="0" cap="none" spc="0" normalizeH="0" baseline="0" noProof="0" dirty="0">
-                <a:ln>
-                  <a:noFill/>
-                </a:ln>
-                <a:solidFill>
-                  <a:srgbClr val="000000"/>
-                </a:solidFill>
-                <a:effectLst/>
-                <a:uLnTx/>
-                <a:uFillTx/>
-              </a:rPr>
-              <a:t> </a:t>
-            </a:r>
-            <a:r>
-              <a:rPr kumimoji="0" lang="de-DE" sz="1200" i="0" u="none" strike="noStrike" kern="0" cap="none" spc="0" normalizeH="0" baseline="0" noProof="0" dirty="0" err="1">
-                <a:ln>
-                  <a:noFill/>
-                </a:ln>
-                <a:solidFill>
-                  <a:srgbClr val="000000"/>
-                </a:solidFill>
-                <a:effectLst/>
-                <a:uLnTx/>
-                <a:uFillTx/>
-              </a:rPr>
-              <a:t>now</a:t>
-            </a:r>
-            <a:r>
-              <a:rPr kumimoji="0" lang="de-DE" sz="1200" i="0" u="none" strike="noStrike" kern="0" cap="none" spc="0" normalizeH="0" baseline="0" noProof="0" dirty="0">
-                <a:ln>
-                  <a:noFill/>
-                </a:ln>
-                <a:solidFill>
-                  <a:srgbClr val="000000"/>
-                </a:solidFill>
-                <a:effectLst/>
-                <a:uLnTx/>
-                <a:uFillTx/>
-              </a:rPr>
-              <a:t>. </a:t>
-            </a:r>
-            <a:r>
-              <a:rPr kumimoji="0" lang="de-DE" sz="1200" i="0" u="none" strike="noStrike" kern="0" cap="none" spc="0" normalizeH="0" baseline="0" noProof="0" dirty="0" err="1">
-                <a:ln>
-                  <a:noFill/>
-                </a:ln>
-                <a:solidFill>
-                  <a:srgbClr val="000000"/>
-                </a:solidFill>
-                <a:effectLst/>
-                <a:uLnTx/>
-                <a:uFillTx/>
-              </a:rPr>
-              <a:t>To</a:t>
-            </a:r>
-            <a:r>
-              <a:rPr kumimoji="0" lang="de-DE" sz="1200" i="0" u="none" strike="noStrike" kern="0" cap="none" spc="0" normalizeH="0" baseline="0" noProof="0" dirty="0">
-                <a:ln>
-                  <a:noFill/>
-                </a:ln>
-                <a:solidFill>
-                  <a:srgbClr val="000000"/>
-                </a:solidFill>
-                <a:effectLst/>
-                <a:uLnTx/>
-                <a:uFillTx/>
-              </a:rPr>
-              <a:t> </a:t>
-            </a:r>
-            <a:r>
-              <a:rPr kumimoji="0" lang="de-DE" sz="1200" i="0" u="none" strike="noStrike" kern="0" cap="none" spc="0" normalizeH="0" baseline="0" noProof="0" dirty="0" err="1">
-                <a:ln>
-                  <a:noFill/>
-                </a:ln>
-                <a:solidFill>
-                  <a:srgbClr val="000000"/>
-                </a:solidFill>
-                <a:effectLst/>
-                <a:uLnTx/>
-                <a:uFillTx/>
-              </a:rPr>
-              <a:t>ensure</a:t>
-            </a:r>
-            <a:r>
-              <a:rPr kumimoji="0" lang="de-DE" sz="1200" i="0" u="none" strike="noStrike" kern="0" cap="none" spc="0" normalizeH="0" baseline="0" noProof="0" dirty="0">
-                <a:ln>
-                  <a:noFill/>
-                </a:ln>
-                <a:solidFill>
-                  <a:srgbClr val="000000"/>
-                </a:solidFill>
-                <a:effectLst/>
-                <a:uLnTx/>
-                <a:uFillTx/>
-              </a:rPr>
-              <a:t> </a:t>
-            </a:r>
-            <a:r>
-              <a:rPr kumimoji="0" lang="de-DE" sz="1200" i="0" u="none" strike="noStrike" kern="0" cap="none" spc="0" normalizeH="0" baseline="0" noProof="0" dirty="0" err="1">
-                <a:ln>
-                  <a:noFill/>
-                </a:ln>
-                <a:solidFill>
-                  <a:srgbClr val="000000"/>
-                </a:solidFill>
-                <a:effectLst/>
-                <a:uLnTx/>
-                <a:uFillTx/>
-              </a:rPr>
-              <a:t>downward</a:t>
-            </a:r>
-            <a:r>
-              <a:rPr kumimoji="0" lang="de-DE" sz="1200" i="0" u="none" strike="noStrike" kern="0" cap="none" spc="0" normalizeH="0" baseline="0" noProof="0" dirty="0">
-                <a:ln>
-                  <a:noFill/>
-                </a:ln>
-                <a:solidFill>
-                  <a:srgbClr val="000000"/>
-                </a:solidFill>
-                <a:effectLst/>
-                <a:uLnTx/>
-                <a:uFillTx/>
-              </a:rPr>
-              <a:t> </a:t>
-            </a:r>
-            <a:r>
-              <a:rPr kumimoji="0" lang="de-DE" sz="1200" i="0" u="none" strike="noStrike" kern="0" cap="none" spc="0" normalizeH="0" baseline="0" noProof="0" dirty="0" err="1">
-                <a:ln>
-                  <a:noFill/>
-                </a:ln>
-                <a:solidFill>
-                  <a:srgbClr val="000000"/>
-                </a:solidFill>
-                <a:effectLst/>
-                <a:uLnTx/>
-                <a:uFillTx/>
-              </a:rPr>
-              <a:t>compatibility</a:t>
-            </a:r>
-            <a:r>
-              <a:rPr kumimoji="0" lang="de-DE" sz="1200" i="0" u="none" strike="noStrike" kern="0" cap="none" spc="0" normalizeH="0" baseline="0" noProof="0" dirty="0">
-                <a:ln>
-                  <a:noFill/>
-                </a:ln>
-                <a:solidFill>
-                  <a:srgbClr val="000000"/>
-                </a:solidFill>
-                <a:effectLst/>
-                <a:uLnTx/>
-                <a:uFillTx/>
-              </a:rPr>
-              <a:t>, </a:t>
-            </a:r>
-            <a:r>
-              <a:rPr kumimoji="0" lang="de-DE" sz="1200" i="0" u="none" strike="noStrike" kern="0" cap="none" spc="0" normalizeH="0" baseline="0" noProof="0" dirty="0" err="1">
-                <a:ln>
-                  <a:noFill/>
-                </a:ln>
-                <a:solidFill>
-                  <a:srgbClr val="000000"/>
-                </a:solidFill>
-                <a:effectLst/>
-                <a:uLnTx/>
-                <a:uFillTx/>
-              </a:rPr>
-              <a:t>they</a:t>
-            </a:r>
-            <a:r>
-              <a:rPr kumimoji="0" lang="de-DE" sz="1200" i="0" u="none" strike="noStrike" kern="0" cap="none" spc="0" normalizeH="0" baseline="0" noProof="0" dirty="0">
-                <a:ln>
-                  <a:noFill/>
-                </a:ln>
-                <a:solidFill>
-                  <a:srgbClr val="000000"/>
-                </a:solidFill>
-                <a:effectLst/>
-                <a:uLnTx/>
-                <a:uFillTx/>
-              </a:rPr>
-              <a:t> </a:t>
-            </a:r>
-            <a:r>
-              <a:rPr kumimoji="0" lang="de-DE" sz="1200" i="0" u="none" strike="noStrike" kern="0" cap="none" spc="0" normalizeH="0" baseline="0" noProof="0" dirty="0" err="1">
-                <a:ln>
-                  <a:noFill/>
-                </a:ln>
-                <a:solidFill>
-                  <a:srgbClr val="000000"/>
-                </a:solidFill>
-                <a:effectLst/>
-                <a:uLnTx/>
-                <a:uFillTx/>
-              </a:rPr>
-              <a:t>are</a:t>
-            </a:r>
-            <a:r>
-              <a:rPr kumimoji="0" lang="de-DE" sz="1200" i="0" u="none" strike="noStrike" kern="0" cap="none" spc="0" normalizeH="0" baseline="0" noProof="0" dirty="0">
-                <a:ln>
-                  <a:noFill/>
-                </a:ln>
-                <a:solidFill>
-                  <a:srgbClr val="000000"/>
-                </a:solidFill>
-                <a:effectLst/>
-                <a:uLnTx/>
-                <a:uFillTx/>
-              </a:rPr>
-              <a:t> </a:t>
-            </a:r>
-            <a:r>
-              <a:rPr kumimoji="0" lang="de-DE" sz="1200" i="0" u="none" strike="noStrike" kern="0" cap="none" spc="0" normalizeH="0" baseline="0" noProof="0" dirty="0" err="1">
-                <a:ln>
-                  <a:noFill/>
-                </a:ln>
-                <a:solidFill>
-                  <a:srgbClr val="000000"/>
-                </a:solidFill>
-                <a:effectLst/>
-                <a:uLnTx/>
-                <a:uFillTx/>
-              </a:rPr>
-              <a:t>mapped</a:t>
-            </a:r>
-            <a:r>
-              <a:rPr kumimoji="0" lang="de-DE" sz="1200" i="0" u="none" strike="noStrike" kern="0" cap="none" spc="0" normalizeH="0" baseline="0" noProof="0" dirty="0">
-                <a:ln>
-                  <a:noFill/>
-                </a:ln>
-                <a:solidFill>
-                  <a:srgbClr val="000000"/>
-                </a:solidFill>
-                <a:effectLst/>
-                <a:uLnTx/>
-                <a:uFillTx/>
-              </a:rPr>
-              <a:t> </a:t>
-            </a:r>
-            <a:r>
-              <a:rPr kumimoji="0" lang="de-DE" sz="1200" i="0" u="none" strike="noStrike" kern="0" cap="none" spc="0" normalizeH="0" baseline="0" noProof="0" dirty="0" err="1">
-                <a:ln>
-                  <a:noFill/>
-                </a:ln>
-                <a:solidFill>
-                  <a:srgbClr val="000000"/>
-                </a:solidFill>
-                <a:effectLst/>
-                <a:uLnTx/>
-                <a:uFillTx/>
-              </a:rPr>
-              <a:t>to</a:t>
-            </a:r>
-            <a:r>
-              <a:rPr kumimoji="0" lang="de-DE" sz="1200" i="0" u="none" strike="noStrike" kern="0" cap="none" spc="0" normalizeH="0" baseline="0" noProof="0" dirty="0">
-                <a:ln>
-                  <a:noFill/>
-                </a:ln>
-                <a:solidFill>
-                  <a:srgbClr val="000000"/>
-                </a:solidFill>
-                <a:effectLst/>
-                <a:uLnTx/>
-                <a:uFillTx/>
-              </a:rPr>
-              <a:t> </a:t>
-            </a:r>
-            <a:r>
-              <a:rPr kumimoji="0" lang="de-DE" sz="1200" i="0" u="none" strike="noStrike" kern="0" cap="none" spc="0" normalizeH="0" baseline="0" noProof="0" dirty="0" err="1">
-                <a:ln>
-                  <a:noFill/>
-                </a:ln>
-                <a:solidFill>
-                  <a:srgbClr val="000000"/>
-                </a:solidFill>
-                <a:effectLst/>
-                <a:uLnTx/>
-                <a:uFillTx/>
-              </a:rPr>
-              <a:t>new</a:t>
-            </a:r>
-            <a:r>
-              <a:rPr kumimoji="0" lang="de-DE" sz="1200" i="0" u="none" strike="noStrike" kern="0" cap="none" spc="0" normalizeH="0" baseline="0" noProof="0" dirty="0">
-                <a:ln>
-                  <a:noFill/>
-                </a:ln>
-                <a:solidFill>
-                  <a:srgbClr val="000000"/>
-                </a:solidFill>
-                <a:effectLst/>
-                <a:uLnTx/>
-                <a:uFillTx/>
-              </a:rPr>
-              <a:t> </a:t>
-            </a:r>
-            <a:r>
-              <a:rPr kumimoji="0" lang="de-DE" sz="1200" i="0" u="none" strike="noStrike" kern="0" cap="none" spc="0" normalizeH="0" baseline="0" noProof="0" dirty="0" err="1">
-                <a:ln>
-                  <a:noFill/>
-                </a:ln>
-                <a:solidFill>
-                  <a:srgbClr val="000000"/>
-                </a:solidFill>
-                <a:effectLst/>
-                <a:uLnTx/>
-                <a:uFillTx/>
-              </a:rPr>
-              <a:t>ones</a:t>
-            </a:r>
-            <a:r>
-              <a:rPr kumimoji="0" lang="de-DE" sz="1200" i="0" u="none" strike="noStrike" kern="0" cap="none" spc="0" normalizeH="0" baseline="0" noProof="0" dirty="0">
-                <a:ln>
-                  <a:noFill/>
-                </a:ln>
-                <a:solidFill>
-                  <a:srgbClr val="000000"/>
-                </a:solidFill>
-                <a:effectLst/>
-                <a:uLnTx/>
-                <a:uFillTx/>
-              </a:rPr>
-              <a:t>.</a:t>
+              <a:t>:</a:t>
             </a:r>
           </a:p>
         </p:txBody>
@@ -21034,20 +23606,14 @@
           <p:cNvPr id="8" name="Tabelle 7">
             <a:extLst>
               <a:ext uri="{FF2B5EF4-FFF2-40B4-BE49-F238E27FC236}">
-                <a16:creationId xmlns:a16="http://schemas.microsoft.com/office/drawing/2014/main" id="{69E6E5FF-4740-1280-6645-8B35F07D7705}"/>
+                <a16:creationId xmlns:a16="http://schemas.microsoft.com/office/drawing/2014/main" id="{2D779D1B-6671-E156-62C6-8ADCB1C07B61}"/>
               </a:ext>
             </a:extLst>
           </p:cNvPr>
           <p:cNvGraphicFramePr>
             <a:graphicFrameLocks noGrp="1"/>
           </p:cNvGraphicFramePr>
-          <p:nvPr>
-            <p:extLst>
-              <p:ext uri="{D42A27DB-BD31-4B8C-83A1-F6EECF244321}">
-                <p14:modId xmlns:p14="http://schemas.microsoft.com/office/powerpoint/2010/main" val="1311365676"/>
-              </p:ext>
-            </p:extLst>
-          </p:nvPr>
+          <p:nvPr/>
         </p:nvGraphicFramePr>
         <p:xfrm>
           <a:off x="2056813" y="1644350"/>
@@ -21598,7 +24164,7 @@
     </p:spTree>
     <p:extLst>
       <p:ext uri="{BB962C8B-B14F-4D97-AF65-F5344CB8AC3E}">
-        <p14:creationId xmlns:p14="http://schemas.microsoft.com/office/powerpoint/2010/main" val="2876854737"/>
+        <p14:creationId xmlns:p14="http://schemas.microsoft.com/office/powerpoint/2010/main" val="3465613338"/>
       </p:ext>
     </p:extLst>
   </p:cSld>
@@ -21608,7 +24174,7 @@
 </p:sld>
 </file>
 
-<file path=ppt/slides/slide8.xml><?xml version="1.0" encoding="utf-8"?>
+<file path=ppt/slides/slide9.xml><?xml version="1.0" encoding="utf-8"?>
 <p:sld xmlns:a="http://schemas.openxmlformats.org/drawingml/2006/main" xmlns:r="http://schemas.openxmlformats.org/officeDocument/2006/relationships" xmlns:p="http://schemas.openxmlformats.org/presentationml/2006/main">
   <p:cSld>
     <p:spTree>
@@ -21684,7 +24250,7 @@
             <a:fld id="{4898AEC0-503E-4FA4-859C-D0F72D6E3F79}" type="slidenum">
               <a:rPr lang="en-US" noProof="1" smtClean="0"/>
               <a:pPr/>
-              <a:t>8</a:t>
+              <a:t>9</a:t>
             </a:fld>
             <a:endParaRPr lang="en-US" noProof="1"/>
           </a:p>
@@ -22615,476 +25181,6 @@
     <p:extLst>
       <p:ext uri="{BB962C8B-B14F-4D97-AF65-F5344CB8AC3E}">
         <p14:creationId xmlns:p14="http://schemas.microsoft.com/office/powerpoint/2010/main" val="2948908536"/>
-      </p:ext>
-    </p:extLst>
-  </p:cSld>
-  <p:clrMapOvr>
-    <a:masterClrMapping/>
-  </p:clrMapOvr>
-</p:sld>
-</file>
-
-<file path=ppt/slides/slide9.xml><?xml version="1.0" encoding="utf-8"?>
-<p:sld xmlns:a="http://schemas.openxmlformats.org/drawingml/2006/main" xmlns:r="http://schemas.openxmlformats.org/officeDocument/2006/relationships" xmlns:p="http://schemas.openxmlformats.org/presentationml/2006/main">
-  <p:cSld>
-    <p:spTree>
-      <p:nvGrpSpPr>
-        <p:cNvPr id="1" name="">
-          <a:extLst>
-            <a:ext uri="{FF2B5EF4-FFF2-40B4-BE49-F238E27FC236}">
-              <a16:creationId xmlns:a16="http://schemas.microsoft.com/office/drawing/2014/main" id="{CC87B0B3-6C56-A6F9-D687-40D1C5E1A8D4}"/>
-            </a:ext>
-          </a:extLst>
-        </p:cNvPr>
-        <p:cNvGrpSpPr/>
-        <p:nvPr/>
-      </p:nvGrpSpPr>
-      <p:grpSpPr>
-        <a:xfrm>
-          <a:off x="0" y="0"/>
-          <a:ext cx="0" cy="0"/>
-          <a:chOff x="0" y="0"/>
-          <a:chExt cx="0" cy="0"/>
-        </a:xfrm>
-      </p:grpSpPr>
-      <p:sp>
-        <p:nvSpPr>
-          <p:cNvPr id="3" name="Textplatzhalter 2">
-            <a:extLst>
-              <a:ext uri="{FF2B5EF4-FFF2-40B4-BE49-F238E27FC236}">
-                <a16:creationId xmlns:a16="http://schemas.microsoft.com/office/drawing/2014/main" id="{EACE1218-8F37-EF62-5767-F9500A4AA160}"/>
-              </a:ext>
-            </a:extLst>
-          </p:cNvPr>
-          <p:cNvSpPr>
-            <a:spLocks noGrp="1"/>
-          </p:cNvSpPr>
-          <p:nvPr>
-            <p:ph type="body" sz="quarter" idx="15"/>
-          </p:nvPr>
-        </p:nvSpPr>
-        <p:spPr/>
-        <p:txBody>
-          <a:bodyPr/>
-          <a:lstStyle/>
-          <a:p>
-            <a:r>
-              <a:rPr lang="de-DE" dirty="0"/>
-              <a:t>Code Objects (2)</a:t>
-            </a:r>
-            <a:endParaRPr lang="en-US" dirty="0"/>
-          </a:p>
-        </p:txBody>
-      </p:sp>
-      <p:sp>
-        <p:nvSpPr>
-          <p:cNvPr id="4" name="Foliennummernplatzhalter 3">
-            <a:extLst>
-              <a:ext uri="{FF2B5EF4-FFF2-40B4-BE49-F238E27FC236}">
-                <a16:creationId xmlns:a16="http://schemas.microsoft.com/office/drawing/2014/main" id="{46741DED-A3B8-781D-FAFD-62F2AB757746}"/>
-              </a:ext>
-            </a:extLst>
-          </p:cNvPr>
-          <p:cNvSpPr>
-            <a:spLocks noGrp="1"/>
-          </p:cNvSpPr>
-          <p:nvPr>
-            <p:ph type="sldNum" sz="quarter" idx="12"/>
-          </p:nvPr>
-        </p:nvSpPr>
-        <p:spPr/>
-        <p:txBody>
-          <a:bodyPr/>
-          <a:lstStyle/>
-          <a:p>
-            <a:fld id="{4898AEC0-503E-4FA4-859C-D0F72D6E3F79}" type="slidenum">
-              <a:rPr lang="en-US" noProof="1" smtClean="0"/>
-              <a:pPr/>
-              <a:t>9</a:t>
-            </a:fld>
-            <a:endParaRPr lang="en-US" noProof="1"/>
-          </a:p>
-        </p:txBody>
-      </p:sp>
-      <p:sp>
-        <p:nvSpPr>
-          <p:cNvPr id="2" name="Textfeld 116">
-            <a:extLst>
-              <a:ext uri="{FF2B5EF4-FFF2-40B4-BE49-F238E27FC236}">
-                <a16:creationId xmlns:a16="http://schemas.microsoft.com/office/drawing/2014/main" id="{D9D477F7-6B63-6CCC-5ED1-02DD6EA87A92}"/>
-              </a:ext>
-            </a:extLst>
-          </p:cNvPr>
-          <p:cNvSpPr txBox="1"/>
-          <p:nvPr/>
-        </p:nvSpPr>
-        <p:spPr>
-          <a:xfrm>
-            <a:off x="266699" y="849988"/>
-            <a:ext cx="5465233" cy="388800"/>
-          </a:xfrm>
-          <a:prstGeom prst="rect">
-            <a:avLst/>
-          </a:prstGeom>
-          <a:noFill/>
-        </p:spPr>
-        <p:txBody>
-          <a:bodyPr wrap="square" lIns="0" tIns="0" rIns="0" bIns="0" rtlCol="0">
-            <a:noAutofit/>
-          </a:bodyPr>
-          <a:lstStyle/>
-          <a:p>
-            <a:pPr marR="0" defTabSz="914400" eaLnBrk="1" fontAlgn="auto" latinLnBrk="0" hangingPunct="1">
-              <a:lnSpc>
-                <a:spcPts val="2300"/>
-              </a:lnSpc>
-              <a:spcBef>
-                <a:spcPts val="500"/>
-              </a:spcBef>
-              <a:spcAft>
-                <a:spcPts val="0"/>
-              </a:spcAft>
-              <a:buClrTx/>
-              <a:buSzTx/>
-              <a:buFontTx/>
-              <a:buNone/>
-              <a:tabLst/>
-            </a:pPr>
-            <a:r>
-              <a:rPr lang="de-DE" b="1" kern="0" dirty="0" err="1">
-                <a:solidFill>
-                  <a:srgbClr val="000000"/>
-                </a:solidFill>
-              </a:rPr>
-              <a:t>class</a:t>
-            </a:r>
-            <a:r>
-              <a:rPr lang="de-DE" b="1" kern="0" dirty="0">
-                <a:solidFill>
-                  <a:srgbClr val="000000"/>
-                </a:solidFill>
-              </a:rPr>
-              <a:t> </a:t>
-            </a:r>
-            <a:r>
-              <a:rPr lang="de-DE" b="1" kern="0" dirty="0" err="1">
-                <a:solidFill>
-                  <a:srgbClr val="000000"/>
-                </a:solidFill>
-              </a:rPr>
-              <a:t>CustomLaTeXTranslator</a:t>
-            </a:r>
-            <a:r>
-              <a:rPr lang="de-DE" b="1" kern="0" dirty="0">
-                <a:solidFill>
-                  <a:srgbClr val="000000"/>
-                </a:solidFill>
-              </a:rPr>
-              <a:t>(</a:t>
-            </a:r>
-            <a:r>
-              <a:rPr lang="de-DE" b="1" kern="0" dirty="0" err="1">
-                <a:solidFill>
-                  <a:srgbClr val="000000"/>
-                </a:solidFill>
-              </a:rPr>
-              <a:t>LaTeXTranslator</a:t>
-            </a:r>
-            <a:r>
-              <a:rPr lang="de-DE" b="1" kern="0" dirty="0">
-                <a:solidFill>
-                  <a:srgbClr val="000000"/>
-                </a:solidFill>
-              </a:rPr>
-              <a:t>):</a:t>
-            </a:r>
-          </a:p>
-        </p:txBody>
-      </p:sp>
-      <p:graphicFrame>
-        <p:nvGraphicFramePr>
-          <p:cNvPr id="38" name="Tabelle 37">
-            <a:extLst>
-              <a:ext uri="{FF2B5EF4-FFF2-40B4-BE49-F238E27FC236}">
-                <a16:creationId xmlns:a16="http://schemas.microsoft.com/office/drawing/2014/main" id="{A0C64C4A-3F37-0BFB-E1E8-F3396992A431}"/>
-              </a:ext>
-            </a:extLst>
-          </p:cNvPr>
-          <p:cNvGraphicFramePr>
-            <a:graphicFrameLocks noGrp="1"/>
-          </p:cNvGraphicFramePr>
-          <p:nvPr>
-            <p:extLst>
-              <p:ext uri="{D42A27DB-BD31-4B8C-83A1-F6EECF244321}">
-                <p14:modId xmlns:p14="http://schemas.microsoft.com/office/powerpoint/2010/main" val="119257365"/>
-              </p:ext>
-            </p:extLst>
-          </p:nvPr>
-        </p:nvGraphicFramePr>
-        <p:xfrm>
-          <a:off x="259200" y="1238788"/>
-          <a:ext cx="10298733" cy="2490203"/>
-        </p:xfrm>
-        <a:graphic>
-          <a:graphicData uri="http://schemas.openxmlformats.org/drawingml/2006/table">
-            <a:tbl>
-              <a:tblPr firstRow="1" bandRow="1">
-                <a:tableStyleId>{F5AB1C69-6EDB-4FF4-983F-18BD219EF322}</a:tableStyleId>
-              </a:tblPr>
-              <a:tblGrid>
-                <a:gridCol w="3432911">
-                  <a:extLst>
-                    <a:ext uri="{9D8B030D-6E8A-4147-A177-3AD203B41FA5}">
-                      <a16:colId xmlns:a16="http://schemas.microsoft.com/office/drawing/2014/main" val="43910445"/>
-                    </a:ext>
-                  </a:extLst>
-                </a:gridCol>
-                <a:gridCol w="3432911">
-                  <a:extLst>
-                    <a:ext uri="{9D8B030D-6E8A-4147-A177-3AD203B41FA5}">
-                      <a16:colId xmlns:a16="http://schemas.microsoft.com/office/drawing/2014/main" val="3741258493"/>
-                    </a:ext>
-                  </a:extLst>
-                </a:gridCol>
-                <a:gridCol w="3432911">
-                  <a:extLst>
-                    <a:ext uri="{9D8B030D-6E8A-4147-A177-3AD203B41FA5}">
-                      <a16:colId xmlns:a16="http://schemas.microsoft.com/office/drawing/2014/main" val="2562324463"/>
-                    </a:ext>
-                  </a:extLst>
-                </a:gridCol>
-              </a:tblGrid>
-              <a:tr h="478523">
-                <a:tc>
-                  <a:txBody>
-                    <a:bodyPr/>
-                    <a:lstStyle/>
-                    <a:p>
-                      <a:r>
-                        <a:rPr lang="de-DE" dirty="0" err="1">
-                          <a:solidFill>
-                            <a:schemeClr val="tx1"/>
-                          </a:solidFill>
-                        </a:rPr>
-                        <a:t>Markdown</a:t>
-                      </a:r>
-                      <a:endParaRPr lang="de-DE" dirty="0">
-                        <a:solidFill>
-                          <a:schemeClr val="tx1"/>
-                        </a:solidFill>
-                      </a:endParaRPr>
-                    </a:p>
-                  </a:txBody>
-                  <a:tcPr/>
-                </a:tc>
-                <a:tc>
-                  <a:txBody>
-                    <a:bodyPr/>
-                    <a:lstStyle/>
-                    <a:p>
-                      <a:r>
-                        <a:rPr lang="de-DE" dirty="0" err="1">
-                          <a:solidFill>
-                            <a:schemeClr val="tx1"/>
-                          </a:solidFill>
-                        </a:rPr>
-                        <a:t>LaTeX</a:t>
-                      </a:r>
-                      <a:endParaRPr lang="de-DE" dirty="0">
-                        <a:solidFill>
-                          <a:schemeClr val="tx1"/>
-                        </a:solidFill>
-                      </a:endParaRPr>
-                    </a:p>
-                  </a:txBody>
-                  <a:tcPr/>
-                </a:tc>
-                <a:tc>
-                  <a:txBody>
-                    <a:bodyPr/>
-                    <a:lstStyle/>
-                    <a:p>
-                      <a:r>
-                        <a:rPr lang="de-DE" dirty="0" err="1">
-                          <a:solidFill>
-                            <a:schemeClr val="tx1"/>
-                          </a:solidFill>
-                        </a:rPr>
-                        <a:t>Realized</a:t>
-                      </a:r>
-                      <a:r>
-                        <a:rPr lang="de-DE" dirty="0">
-                          <a:solidFill>
-                            <a:schemeClr val="tx1"/>
-                          </a:solidFill>
-                        </a:rPr>
-                        <a:t> </a:t>
-                      </a:r>
-                      <a:r>
-                        <a:rPr lang="de-DE" dirty="0" err="1">
-                          <a:solidFill>
-                            <a:schemeClr val="tx1"/>
-                          </a:solidFill>
-                        </a:rPr>
-                        <a:t>by</a:t>
-                      </a:r>
-                      <a:endParaRPr lang="de-DE" dirty="0">
-                        <a:solidFill>
-                          <a:schemeClr val="tx1"/>
-                        </a:solidFill>
-                      </a:endParaRPr>
-                    </a:p>
-                  </a:txBody>
-                  <a:tcPr/>
-                </a:tc>
-                <a:extLst>
-                  <a:ext uri="{0D108BD9-81ED-4DB2-BD59-A6C34878D82A}">
-                    <a16:rowId xmlns:a16="http://schemas.microsoft.com/office/drawing/2014/main" val="3297251498"/>
-                  </a:ext>
-                </a:extLst>
-              </a:tr>
-              <a:tr h="485169">
-                <a:tc>
-                  <a:txBody>
-                    <a:bodyPr/>
-                    <a:lstStyle/>
-                    <a:p>
-                      <a:r>
-                        <a:rPr lang="de-DE" dirty="0" err="1"/>
-                        <a:t>directive</a:t>
-                      </a:r>
-                      <a:r>
-                        <a:rPr lang="de-DE" dirty="0"/>
-                        <a:t>/</a:t>
-                      </a:r>
-                      <a:r>
-                        <a:rPr lang="de-DE" dirty="0" err="1"/>
-                        <a:t>rule</a:t>
-                      </a:r>
-                      <a:endParaRPr lang="de-DE" dirty="0"/>
-                    </a:p>
-                  </a:txBody>
-                  <a:tcPr/>
-                </a:tc>
-                <a:tc>
-                  <a:txBody>
-                    <a:bodyPr/>
-                    <a:lstStyle/>
-                    <a:p>
-                      <a:r>
-                        <a:rPr lang="de-DE" dirty="0" err="1"/>
-                        <a:t>environment</a:t>
-                      </a:r>
-                      <a:r>
-                        <a:rPr lang="de-DE" dirty="0"/>
-                        <a:t>/</a:t>
-                      </a:r>
-                      <a:r>
-                        <a:rPr lang="de-DE" dirty="0" err="1"/>
-                        <a:t>command</a:t>
-                      </a:r>
-                      <a:endParaRPr lang="de-DE" dirty="0"/>
-                    </a:p>
-                  </a:txBody>
-                  <a:tcPr/>
-                </a:tc>
-                <a:tc>
-                  <a:txBody>
-                    <a:bodyPr/>
-                    <a:lstStyle/>
-                    <a:p>
-                      <a:r>
-                        <a:rPr lang="en-US" dirty="0">
-                          <a:latin typeface="72 Monospace" panose="020B0509030603020204" pitchFamily="49" charset="0"/>
-                          <a:cs typeface="72 Monospace" panose="020B0509030603020204" pitchFamily="49" charset="0"/>
-                        </a:rPr>
-                        <a:t>from </a:t>
-                      </a:r>
-                      <a:r>
-                        <a:rPr lang="en-US" dirty="0" err="1">
-                          <a:latin typeface="72 Monospace" panose="020B0509030603020204" pitchFamily="49" charset="0"/>
-                          <a:cs typeface="72 Monospace" panose="020B0509030603020204" pitchFamily="49" charset="0"/>
-                        </a:rPr>
-                        <a:t>docutils.core</a:t>
-                      </a:r>
-                      <a:r>
-                        <a:rPr lang="en-US" dirty="0">
-                          <a:latin typeface="72 Monospace" panose="020B0509030603020204" pitchFamily="49" charset="0"/>
-                          <a:cs typeface="72 Monospace" panose="020B0509030603020204" pitchFamily="49" charset="0"/>
-                        </a:rPr>
-                        <a:t> import </a:t>
-                      </a:r>
-                      <a:r>
-                        <a:rPr lang="en-US" dirty="0" err="1">
-                          <a:latin typeface="72 Monospace" panose="020B0509030603020204" pitchFamily="49" charset="0"/>
-                          <a:cs typeface="72 Monospace" panose="020B0509030603020204" pitchFamily="49" charset="0"/>
-                        </a:rPr>
-                        <a:t>publish_parts</a:t>
-                      </a:r>
-                      <a:endParaRPr lang="en-US" dirty="0">
-                        <a:latin typeface="72 Monospace" panose="020B0509030603020204" pitchFamily="49" charset="0"/>
-                        <a:cs typeface="72 Monospace" panose="020B0509030603020204" pitchFamily="49" charset="0"/>
-                      </a:endParaRPr>
-                    </a:p>
-                    <a:p>
-                      <a:endParaRPr lang="en-US" dirty="0"/>
-                    </a:p>
-                    <a:p>
-                      <a:r>
-                        <a:rPr lang="en-US" dirty="0"/>
-                        <a:t>With:</a:t>
-                      </a:r>
-                    </a:p>
-                    <a:p>
-                      <a:endParaRPr lang="en-US" dirty="0"/>
-                    </a:p>
-                    <a:p>
-                      <a:r>
-                        <a:rPr lang="de-DE" dirty="0" err="1">
-                          <a:latin typeface="72 Monospace" panose="020B0509030603020204" pitchFamily="49" charset="0"/>
-                          <a:cs typeface="72 Monospace" panose="020B0509030603020204" pitchFamily="49" charset="0"/>
-                        </a:rPr>
-                        <a:t>writer</a:t>
-                      </a:r>
-                      <a:r>
-                        <a:rPr lang="de-DE" dirty="0">
-                          <a:latin typeface="72 Monospace" panose="020B0509030603020204" pitchFamily="49" charset="0"/>
-                          <a:cs typeface="72 Monospace" panose="020B0509030603020204" pitchFamily="49" charset="0"/>
-                        </a:rPr>
-                        <a:t>=</a:t>
-                      </a:r>
-                      <a:r>
-                        <a:rPr lang="de-DE" dirty="0" err="1">
-                          <a:latin typeface="72 Monospace" panose="020B0509030603020204" pitchFamily="49" charset="0"/>
-                          <a:cs typeface="72 Monospace" panose="020B0509030603020204" pitchFamily="49" charset="0"/>
-                        </a:rPr>
-                        <a:t>CustomLaTeXWriter</a:t>
-                      </a:r>
-                      <a:r>
-                        <a:rPr lang="de-DE" dirty="0">
-                          <a:latin typeface="72 Monospace" panose="020B0509030603020204" pitchFamily="49" charset="0"/>
-                          <a:cs typeface="72 Monospace" panose="020B0509030603020204" pitchFamily="49" charset="0"/>
-                        </a:rPr>
-                        <a:t>()</a:t>
-                      </a:r>
-                    </a:p>
-                  </a:txBody>
-                  <a:tcPr/>
-                </a:tc>
-                <a:extLst>
-                  <a:ext uri="{0D108BD9-81ED-4DB2-BD59-A6C34878D82A}">
-                    <a16:rowId xmlns:a16="http://schemas.microsoft.com/office/drawing/2014/main" val="3909443894"/>
-                  </a:ext>
-                </a:extLst>
-              </a:tr>
-            </a:tbl>
-          </a:graphicData>
-        </a:graphic>
-      </p:graphicFrame>
-    </p:spTree>
-    <p:extLst>
-      <p:ext uri="{BB962C8B-B14F-4D97-AF65-F5344CB8AC3E}">
-        <p14:creationId xmlns:p14="http://schemas.microsoft.com/office/powerpoint/2010/main" val="763922602"/>
       </p:ext>
     </p:extLst>
   </p:cSld>
@@ -23817,6 +25913,33 @@
 </file>
 
 <file path=customXml/item1.xml><?xml version="1.0" encoding="utf-8"?>
+<sax_ColorSelect>
+  <Line>
+    <Color val="D70012"/>
+    <Color val="EA6876"/>
+    <Color val="a80163"/>
+    <Color val="D067AD"/>
+    <Color val="3f136c"/>
+    <Color val="967CB1"/>
+    <Color val="08427e"/>
+    <Color val="6D9ABC"/>
+    <Color val="0e78c5"/>
+    <Color val="6FB9E2"/>
+    <Color val="1399a0"/>
+    <Color val="6FC9CC"/>
+    <Color val="67b419"/>
+    <Color val="AEDB7D"/>
+    <Color val="0a5139"/>
+    <Color val="6EA293"/>
+    <Color val="999FA6"/>
+    <Color val="D7D7D7"/>
+    <Color val="000000"/>
+    <Color val="FFFFFF"/>
+  </Line>
+</sax_ColorSelect>
+</file>
+
+<file path=customXml/item2.xml><?xml version="1.0" encoding="utf-8"?>
 <saxML>
   <saxMLTemplate>presentation_169</saxMLTemplate>
   <Variablen>
@@ -23965,41 +26088,14 @@
 </saxML>
 </file>
 
-<file path=customXml/item2.xml><?xml version="1.0" encoding="utf-8"?>
-<sax_ColorSelect>
-  <Line>
-    <Color val="D70012"/>
-    <Color val="EA6876"/>
-    <Color val="a80163"/>
-    <Color val="D067AD"/>
-    <Color val="3f136c"/>
-    <Color val="967CB1"/>
-    <Color val="08427e"/>
-    <Color val="6D9ABC"/>
-    <Color val="0e78c5"/>
-    <Color val="6FB9E2"/>
-    <Color val="1399a0"/>
-    <Color val="6FC9CC"/>
-    <Color val="67b419"/>
-    <Color val="AEDB7D"/>
-    <Color val="0a5139"/>
-    <Color val="6EA293"/>
-    <Color val="999FA6"/>
-    <Color val="D7D7D7"/>
-    <Color val="000000"/>
-    <Color val="FFFFFF"/>
-  </Line>
-</sax_ColorSelect>
-</file>
-
 <file path=customXml/itemProps1.xml><?xml version="1.0" encoding="utf-8"?>
-<ds:datastoreItem xmlns:ds="http://schemas.openxmlformats.org/officeDocument/2006/customXml" ds:itemID="{0C448C28-9EEA-4021-9490-0728716AEC26}">
+<ds:datastoreItem xmlns:ds="http://schemas.openxmlformats.org/officeDocument/2006/customXml" ds:itemID="{304CF217-3C90-4AA0-B541-CE45F9BD305E}">
   <ds:schemaRefs/>
 </ds:datastoreItem>
 </file>
 
 <file path=customXml/itemProps2.xml><?xml version="1.0" encoding="utf-8"?>
-<ds:datastoreItem xmlns:ds="http://schemas.openxmlformats.org/officeDocument/2006/customXml" ds:itemID="{304CF217-3C90-4AA0-B541-CE45F9BD305E}">
+<ds:datastoreItem xmlns:ds="http://schemas.openxmlformats.org/officeDocument/2006/customXml" ds:itemID="{0C448C28-9EEA-4021-9490-0728716AEC26}">
   <ds:schemaRefs/>
 </ds:datastoreItem>
 </file>
</xml_diff>